<commit_message>
Added slides about overview and architecture behind Grounding DINO
</commit_message>
<xml_diff>
--- a/presentations/Prezentacja_ADOM.pptx
+++ b/presentations/Prezentacja_ADOM.pptx
@@ -509,6 +509,1286 @@
 </p:notesMaster>
 </file>
 
+<file path=ppt/notesSlides/notesSlide1.xml><?xml version="1.0" encoding="utf-8"?>
+<p:notes xmlns:a="http://schemas.openxmlformats.org/drawingml/2006/main" xmlns:r="http://schemas.openxmlformats.org/officeDocument/2006/relationships" xmlns:p="http://schemas.openxmlformats.org/presentationml/2006/main">
+  <p:cSld>
+    <p:spTree>
+      <p:nvGrpSpPr>
+        <p:cNvPr id="1" name=""/>
+        <p:cNvGrpSpPr/>
+        <p:nvPr/>
+      </p:nvGrpSpPr>
+      <p:grpSpPr>
+        <a:xfrm>
+          <a:off x="0" y="0"/>
+          <a:ext cx="0" cy="0"/>
+          <a:chOff x="0" y="0"/>
+          <a:chExt cx="0" cy="0"/>
+        </a:xfrm>
+      </p:grpSpPr>
+      <p:sp>
+        <p:nvSpPr>
+          <p:cNvPr id="2" name="Symbol zastępczy obrazu slajdu 1"/>
+          <p:cNvSpPr>
+            <a:spLocks noGrp="1" noRot="1" noChangeAspect="1"/>
+          </p:cNvSpPr>
+          <p:nvPr>
+            <p:ph type="sldImg"/>
+          </p:nvPr>
+        </p:nvSpPr>
+        <p:spPr>
+          <a:xfrm>
+            <a:off x="381000" y="685800"/>
+            <a:ext cx="6096000" cy="3429000"/>
+          </a:xfrm>
+        </p:spPr>
+      </p:sp>
+      <p:sp>
+        <p:nvSpPr>
+          <p:cNvPr id="3" name="Symbol zastępczy notatek 2"/>
+          <p:cNvSpPr>
+            <a:spLocks noGrp="1"/>
+          </p:cNvSpPr>
+          <p:nvPr>
+            <p:ph type="body" idx="1"/>
+          </p:nvPr>
+        </p:nvSpPr>
+        <p:spPr/>
+        <p:txBody>
+          <a:bodyPr/>
+          <a:lstStyle/>
+          <a:p>
+            <a:pPr lvl="0"/>
+            <a:r>
+              <a:rPr lang="pl-PL" sz="2800" b="1" dirty="0">
+                <a:effectLst/>
+                <a:latin typeface="+mn-lt"/>
+                <a:ea typeface="+mn-ea"/>
+                <a:cs typeface="+mn-cs"/>
+                <a:sym typeface="Times New Roman"/>
+              </a:rPr>
+              <a:t>Open-set </a:t>
+            </a:r>
+            <a:r>
+              <a:rPr lang="pl-PL" sz="2800" b="1" dirty="0" err="1">
+                <a:effectLst/>
+                <a:latin typeface="+mn-lt"/>
+                <a:ea typeface="+mn-ea"/>
+                <a:cs typeface="+mn-cs"/>
+                <a:sym typeface="Times New Roman"/>
+              </a:rPr>
+              <a:t>object</a:t>
+            </a:r>
+            <a:r>
+              <a:rPr lang="pl-PL" sz="2800" b="1" dirty="0">
+                <a:effectLst/>
+                <a:latin typeface="+mn-lt"/>
+                <a:ea typeface="+mn-ea"/>
+                <a:cs typeface="+mn-cs"/>
+                <a:sym typeface="Times New Roman"/>
+              </a:rPr>
+              <a:t> </a:t>
+            </a:r>
+            <a:r>
+              <a:rPr lang="pl-PL" sz="2800" b="1" dirty="0" err="1">
+                <a:effectLst/>
+                <a:latin typeface="+mn-lt"/>
+                <a:ea typeface="+mn-ea"/>
+                <a:cs typeface="+mn-cs"/>
+                <a:sym typeface="Times New Roman"/>
+              </a:rPr>
+              <a:t>detection</a:t>
+            </a:r>
+            <a:r>
+              <a:rPr lang="pl-PL" sz="2800" b="1" dirty="0">
+                <a:effectLst/>
+                <a:latin typeface="+mn-lt"/>
+                <a:ea typeface="+mn-ea"/>
+                <a:cs typeface="+mn-cs"/>
+                <a:sym typeface="Times New Roman"/>
+              </a:rPr>
+              <a:t> (Detekcja w zbiorze otwartym):</a:t>
+            </a:r>
+            <a:r>
+              <a:rPr lang="pl-PL" sz="2800" dirty="0">
+                <a:effectLst/>
+                <a:latin typeface="+mn-lt"/>
+                <a:ea typeface="+mn-ea"/>
+                <a:cs typeface="+mn-cs"/>
+                <a:sym typeface="Times New Roman"/>
+              </a:rPr>
+              <a:t> Zdolność modelu do lokalizowania i rozpoznawania obiektów, które </a:t>
+            </a:r>
+            <a:r>
+              <a:rPr lang="pl-PL" sz="2800" b="1" dirty="0">
+                <a:effectLst/>
+                <a:latin typeface="+mn-lt"/>
+                <a:ea typeface="+mn-ea"/>
+                <a:cs typeface="+mn-cs"/>
+                <a:sym typeface="Times New Roman"/>
+              </a:rPr>
+              <a:t>nie znajdowały się w zamkniętej liście klas treningowych</a:t>
+            </a:r>
+            <a:r>
+              <a:rPr lang="pl-PL" sz="2800" dirty="0">
+                <a:effectLst/>
+                <a:latin typeface="+mn-lt"/>
+                <a:ea typeface="+mn-ea"/>
+                <a:cs typeface="+mn-cs"/>
+                <a:sym typeface="Times New Roman"/>
+              </a:rPr>
+              <a:t>. Zamiast sztywnego zestawu etykiet (np. 80 klas z COCO), klasami sterujemy dowolnym tekstem w języku naturalnym, w tym pełnymi opisami z cechami i relacjami (</a:t>
+            </a:r>
+            <a:r>
+              <a:rPr lang="pl-PL" sz="2800" i="1" dirty="0" err="1">
+                <a:effectLst/>
+                <a:latin typeface="+mn-lt"/>
+                <a:ea typeface="+mn-ea"/>
+                <a:cs typeface="+mn-cs"/>
+                <a:sym typeface="Times New Roman"/>
+              </a:rPr>
+              <a:t>Referring</a:t>
+            </a:r>
+            <a:r>
+              <a:rPr lang="pl-PL" sz="2800" i="1" dirty="0">
+                <a:effectLst/>
+                <a:latin typeface="+mn-lt"/>
+                <a:ea typeface="+mn-ea"/>
+                <a:cs typeface="+mn-cs"/>
+                <a:sym typeface="Times New Roman"/>
+              </a:rPr>
+              <a:t> </a:t>
+            </a:r>
+            <a:r>
+              <a:rPr lang="pl-PL" sz="2800" i="1" dirty="0" err="1">
+                <a:effectLst/>
+                <a:latin typeface="+mn-lt"/>
+                <a:ea typeface="+mn-ea"/>
+                <a:cs typeface="+mn-cs"/>
+                <a:sym typeface="Times New Roman"/>
+              </a:rPr>
+              <a:t>Expression</a:t>
+            </a:r>
+            <a:r>
+              <a:rPr lang="pl-PL" sz="2800" i="1" dirty="0">
+                <a:effectLst/>
+                <a:latin typeface="+mn-lt"/>
+                <a:ea typeface="+mn-ea"/>
+                <a:cs typeface="+mn-cs"/>
+                <a:sym typeface="Times New Roman"/>
+              </a:rPr>
+              <a:t> </a:t>
+            </a:r>
+            <a:r>
+              <a:rPr lang="pl-PL" sz="2800" i="1" dirty="0" err="1">
+                <a:effectLst/>
+                <a:latin typeface="+mn-lt"/>
+                <a:ea typeface="+mn-ea"/>
+                <a:cs typeface="+mn-cs"/>
+                <a:sym typeface="Times New Roman"/>
+              </a:rPr>
+              <a:t>Comprehension</a:t>
+            </a:r>
+            <a:r>
+              <a:rPr lang="pl-PL" sz="2800" dirty="0">
+                <a:effectLst/>
+                <a:latin typeface="+mn-lt"/>
+                <a:ea typeface="+mn-ea"/>
+                <a:cs typeface="+mn-cs"/>
+                <a:sym typeface="Times New Roman"/>
+              </a:rPr>
+              <a:t>). </a:t>
+            </a:r>
+          </a:p>
+          <a:p>
+            <a:pPr lvl="0"/>
+            <a:r>
+              <a:rPr lang="pl-PL" sz="2800" b="1" dirty="0" err="1">
+                <a:effectLst/>
+                <a:latin typeface="+mn-lt"/>
+                <a:ea typeface="+mn-ea"/>
+                <a:cs typeface="+mn-cs"/>
+                <a:sym typeface="Times New Roman"/>
+              </a:rPr>
+              <a:t>Grounded</a:t>
+            </a:r>
+            <a:r>
+              <a:rPr lang="pl-PL" sz="2800" b="1" dirty="0">
+                <a:effectLst/>
+                <a:latin typeface="+mn-lt"/>
+                <a:ea typeface="+mn-ea"/>
+                <a:cs typeface="+mn-cs"/>
+                <a:sym typeface="Times New Roman"/>
+              </a:rPr>
+              <a:t> </a:t>
+            </a:r>
+            <a:r>
+              <a:rPr lang="pl-PL" sz="2800" b="1" dirty="0" err="1">
+                <a:effectLst/>
+                <a:latin typeface="+mn-lt"/>
+                <a:ea typeface="+mn-ea"/>
+                <a:cs typeface="+mn-cs"/>
+                <a:sym typeface="Times New Roman"/>
+              </a:rPr>
+              <a:t>Pre</a:t>
+            </a:r>
+            <a:r>
+              <a:rPr lang="pl-PL" sz="2800" b="1" dirty="0">
+                <a:effectLst/>
+                <a:latin typeface="+mn-lt"/>
+                <a:ea typeface="+mn-ea"/>
+                <a:cs typeface="+mn-cs"/>
+                <a:sym typeface="Times New Roman"/>
+              </a:rPr>
+              <a:t>-Training (</a:t>
+            </a:r>
+            <a:r>
+              <a:rPr lang="pl-PL" sz="2800" b="1" dirty="0" err="1">
+                <a:effectLst/>
+                <a:latin typeface="+mn-lt"/>
+                <a:ea typeface="+mn-ea"/>
+                <a:cs typeface="+mn-cs"/>
+                <a:sym typeface="Times New Roman"/>
+              </a:rPr>
+              <a:t>Pre-training</a:t>
+            </a:r>
+            <a:r>
+              <a:rPr lang="pl-PL" sz="2800" b="1" dirty="0">
+                <a:effectLst/>
+                <a:latin typeface="+mn-lt"/>
+                <a:ea typeface="+mn-ea"/>
+                <a:cs typeface="+mn-cs"/>
+                <a:sym typeface="Times New Roman"/>
+              </a:rPr>
+              <a:t> z zakorzenieniem tekstu w obrazie):</a:t>
+            </a:r>
+            <a:r>
+              <a:rPr lang="pl-PL" sz="2800" dirty="0">
+                <a:effectLst/>
+                <a:latin typeface="+mn-lt"/>
+                <a:ea typeface="+mn-ea"/>
+                <a:cs typeface="+mn-cs"/>
+                <a:sym typeface="Times New Roman"/>
+              </a:rPr>
+              <a:t> Metodyka trenowania modelu na ogromnych zbiorach danych, gdzie zadanie detekcji jest sformułowane jako dopasowywanie konkretnych fraz tekstowych do regionów obrazu (</a:t>
+            </a:r>
+            <a:r>
+              <a:rPr lang="pl-PL" sz="2800" i="1" dirty="0" err="1">
+                <a:effectLst/>
+                <a:latin typeface="+mn-lt"/>
+                <a:ea typeface="+mn-ea"/>
+                <a:cs typeface="+mn-cs"/>
+                <a:sym typeface="Times New Roman"/>
+              </a:rPr>
+              <a:t>phrase</a:t>
+            </a:r>
+            <a:r>
+              <a:rPr lang="pl-PL" sz="2800" i="1" dirty="0">
+                <a:effectLst/>
+                <a:latin typeface="+mn-lt"/>
+                <a:ea typeface="+mn-ea"/>
+                <a:cs typeface="+mn-cs"/>
+                <a:sym typeface="Times New Roman"/>
+              </a:rPr>
+              <a:t> </a:t>
+            </a:r>
+            <a:r>
+              <a:rPr lang="pl-PL" sz="2800" i="1" dirty="0" err="1">
+                <a:effectLst/>
+                <a:latin typeface="+mn-lt"/>
+                <a:ea typeface="+mn-ea"/>
+                <a:cs typeface="+mn-cs"/>
+                <a:sym typeface="Times New Roman"/>
+              </a:rPr>
+              <a:t>grounding</a:t>
+            </a:r>
+            <a:r>
+              <a:rPr lang="pl-PL" sz="2800" dirty="0">
+                <a:effectLst/>
+                <a:latin typeface="+mn-lt"/>
+                <a:ea typeface="+mn-ea"/>
+                <a:cs typeface="+mn-cs"/>
+                <a:sym typeface="Times New Roman"/>
+              </a:rPr>
+              <a:t>). Zamiast klasyfikatora z jedną warstwą wyjściową, model uczy się wspólnej przestrzeni cech obrazu i tekstu za pomocą straty kontrastowej (</a:t>
+            </a:r>
+            <a:r>
+              <a:rPr lang="pl-PL" sz="2800" i="1" dirty="0" err="1">
+                <a:effectLst/>
+                <a:latin typeface="+mn-lt"/>
+                <a:ea typeface="+mn-ea"/>
+                <a:cs typeface="+mn-cs"/>
+                <a:sym typeface="Times New Roman"/>
+              </a:rPr>
+              <a:t>contrastive</a:t>
+            </a:r>
+            <a:r>
+              <a:rPr lang="pl-PL" sz="2800" i="1" dirty="0">
+                <a:effectLst/>
+                <a:latin typeface="+mn-lt"/>
+                <a:ea typeface="+mn-ea"/>
+                <a:cs typeface="+mn-cs"/>
+                <a:sym typeface="Times New Roman"/>
+              </a:rPr>
+              <a:t> </a:t>
+            </a:r>
+            <a:r>
+              <a:rPr lang="pl-PL" sz="2800" i="1" dirty="0" err="1">
+                <a:effectLst/>
+                <a:latin typeface="+mn-lt"/>
+                <a:ea typeface="+mn-ea"/>
+                <a:cs typeface="+mn-cs"/>
+                <a:sym typeface="Times New Roman"/>
+              </a:rPr>
+              <a:t>loss</a:t>
+            </a:r>
+            <a:r>
+              <a:rPr lang="pl-PL" sz="2800" dirty="0">
+                <a:effectLst/>
+                <a:latin typeface="+mn-lt"/>
+                <a:ea typeface="+mn-ea"/>
+                <a:cs typeface="+mn-cs"/>
+                <a:sym typeface="Times New Roman"/>
+              </a:rPr>
+              <a:t>). </a:t>
+            </a:r>
+          </a:p>
+          <a:p>
+            <a:pPr lvl="0"/>
+            <a:r>
+              <a:rPr lang="pl-PL" sz="2800" b="1" dirty="0" err="1">
+                <a:effectLst/>
+                <a:latin typeface="+mn-lt"/>
+                <a:ea typeface="+mn-ea"/>
+                <a:cs typeface="+mn-cs"/>
+                <a:sym typeface="Times New Roman"/>
+              </a:rPr>
+              <a:t>Sub-sentence</a:t>
+            </a:r>
+            <a:r>
+              <a:rPr lang="pl-PL" sz="2800" b="1" dirty="0">
+                <a:effectLst/>
+                <a:latin typeface="+mn-lt"/>
+                <a:ea typeface="+mn-ea"/>
+                <a:cs typeface="+mn-cs"/>
+                <a:sym typeface="Times New Roman"/>
+              </a:rPr>
+              <a:t> </a:t>
+            </a:r>
+            <a:r>
+              <a:rPr lang="pl-PL" sz="2800" b="1" dirty="0" err="1">
+                <a:effectLst/>
+                <a:latin typeface="+mn-lt"/>
+                <a:ea typeface="+mn-ea"/>
+                <a:cs typeface="+mn-cs"/>
+                <a:sym typeface="Times New Roman"/>
+              </a:rPr>
+              <a:t>level</a:t>
+            </a:r>
+            <a:r>
+              <a:rPr lang="pl-PL" sz="2800" b="1" dirty="0">
+                <a:effectLst/>
+                <a:latin typeface="+mn-lt"/>
+                <a:ea typeface="+mn-ea"/>
+                <a:cs typeface="+mn-cs"/>
+                <a:sym typeface="Times New Roman"/>
+              </a:rPr>
+              <a:t> </a:t>
+            </a:r>
+            <a:r>
+              <a:rPr lang="pl-PL" sz="2800" b="1" dirty="0" err="1">
+                <a:effectLst/>
+                <a:latin typeface="+mn-lt"/>
+                <a:ea typeface="+mn-ea"/>
+                <a:cs typeface="+mn-cs"/>
+                <a:sym typeface="Times New Roman"/>
+              </a:rPr>
+              <a:t>text</a:t>
+            </a:r>
+            <a:r>
+              <a:rPr lang="pl-PL" sz="2800" b="1" dirty="0">
+                <a:effectLst/>
+                <a:latin typeface="+mn-lt"/>
+                <a:ea typeface="+mn-ea"/>
+                <a:cs typeface="+mn-cs"/>
+                <a:sym typeface="Times New Roman"/>
+              </a:rPr>
+              <a:t> </a:t>
+            </a:r>
+            <a:r>
+              <a:rPr lang="pl-PL" sz="2800" b="1" dirty="0" err="1">
+                <a:effectLst/>
+                <a:latin typeface="+mn-lt"/>
+                <a:ea typeface="+mn-ea"/>
+                <a:cs typeface="+mn-cs"/>
+                <a:sym typeface="Times New Roman"/>
+              </a:rPr>
+              <a:t>representation</a:t>
+            </a:r>
+            <a:r>
+              <a:rPr lang="pl-PL" sz="2800" b="1" dirty="0">
+                <a:effectLst/>
+                <a:latin typeface="+mn-lt"/>
+                <a:ea typeface="+mn-ea"/>
+                <a:cs typeface="+mn-cs"/>
+                <a:sym typeface="Times New Roman"/>
+              </a:rPr>
+              <a:t> (Reprezentacja tekstu na poziomie pod-zdań):</a:t>
+            </a:r>
+            <a:r>
+              <a:rPr lang="pl-PL" sz="2800" dirty="0">
+                <a:effectLst/>
+                <a:latin typeface="+mn-lt"/>
+                <a:ea typeface="+mn-ea"/>
+                <a:cs typeface="+mn-cs"/>
+                <a:sym typeface="Times New Roman"/>
+              </a:rPr>
+              <a:t> Innowacyjny sposób kodowania tekstu wprowadzony w Grounding DINO. Gdy do </a:t>
+            </a:r>
+            <a:r>
+              <a:rPr lang="pl-PL" sz="2800" dirty="0" err="1">
+                <a:effectLst/>
+                <a:latin typeface="+mn-lt"/>
+                <a:ea typeface="+mn-ea"/>
+                <a:cs typeface="+mn-cs"/>
+                <a:sym typeface="Times New Roman"/>
+              </a:rPr>
+              <a:t>promptu</a:t>
+            </a:r>
+            <a:r>
+              <a:rPr lang="pl-PL" sz="2800" dirty="0">
+                <a:effectLst/>
+                <a:latin typeface="+mn-lt"/>
+                <a:ea typeface="+mn-ea"/>
+                <a:cs typeface="+mn-cs"/>
+                <a:sym typeface="Times New Roman"/>
+              </a:rPr>
+              <a:t> wrzucamy wiele niezależnych nazw klas (np. </a:t>
+            </a:r>
+            <a:r>
+              <a:rPr lang="pl-PL" sz="2800" i="1" dirty="0">
+                <a:effectLst/>
+                <a:latin typeface="+mn-lt"/>
+                <a:ea typeface="+mn-ea"/>
+                <a:cs typeface="+mn-cs"/>
+                <a:sym typeface="Times New Roman"/>
+              </a:rPr>
+              <a:t>„</a:t>
+            </a:r>
+            <a:r>
+              <a:rPr lang="pl-PL" sz="2800" i="1" dirty="0" err="1">
+                <a:effectLst/>
+                <a:latin typeface="+mn-lt"/>
+                <a:ea typeface="+mn-ea"/>
+                <a:cs typeface="+mn-cs"/>
+                <a:sym typeface="Times New Roman"/>
+              </a:rPr>
+              <a:t>cat</a:t>
+            </a:r>
+            <a:r>
+              <a:rPr lang="pl-PL" sz="2800" i="1" dirty="0">
+                <a:effectLst/>
+                <a:latin typeface="+mn-lt"/>
+                <a:ea typeface="+mn-ea"/>
+                <a:cs typeface="+mn-cs"/>
+                <a:sym typeface="Times New Roman"/>
+              </a:rPr>
+              <a:t>. person. dog.”</a:t>
+            </a:r>
+            <a:r>
+              <a:rPr lang="pl-PL" sz="2800" dirty="0">
+                <a:effectLst/>
+                <a:latin typeface="+mn-lt"/>
+                <a:ea typeface="+mn-ea"/>
+                <a:cs typeface="+mn-cs"/>
+                <a:sym typeface="Times New Roman"/>
+              </a:rPr>
+              <a:t>), zwykły mechanizm atencji mieszałby ich znaczenia. Grounding DINO stosuje </a:t>
+            </a:r>
+            <a:r>
+              <a:rPr lang="pl-PL" sz="2800" b="1" dirty="0">
+                <a:effectLst/>
+                <a:latin typeface="+mn-lt"/>
+                <a:ea typeface="+mn-ea"/>
+                <a:cs typeface="+mn-cs"/>
+                <a:sym typeface="Times New Roman"/>
+              </a:rPr>
+              <a:t>specjalne maski atencji</a:t>
+            </a:r>
+            <a:r>
+              <a:rPr lang="pl-PL" sz="2800" dirty="0">
+                <a:effectLst/>
+                <a:latin typeface="+mn-lt"/>
+                <a:ea typeface="+mn-ea"/>
+                <a:cs typeface="+mn-cs"/>
+                <a:sym typeface="Times New Roman"/>
+              </a:rPr>
+              <a:t>, które blokują interakcję między niespokrewnionymi pojęciami, zachowując jednocześnie szczegółowe cechy na poziomie pojedynczych słów (</a:t>
+            </a:r>
+            <a:r>
+              <a:rPr lang="pl-PL" sz="2800" i="1" dirty="0">
+                <a:effectLst/>
+                <a:latin typeface="+mn-lt"/>
+                <a:ea typeface="+mn-ea"/>
+                <a:cs typeface="+mn-cs"/>
+                <a:sym typeface="Times New Roman"/>
+              </a:rPr>
+              <a:t>per-</a:t>
+            </a:r>
+            <a:r>
+              <a:rPr lang="pl-PL" sz="2800" i="1" dirty="0" err="1">
+                <a:effectLst/>
+                <a:latin typeface="+mn-lt"/>
+                <a:ea typeface="+mn-ea"/>
+                <a:cs typeface="+mn-cs"/>
+                <a:sym typeface="Times New Roman"/>
+              </a:rPr>
+              <a:t>word</a:t>
+            </a:r>
+            <a:r>
+              <a:rPr lang="pl-PL" sz="2800" i="1" dirty="0">
+                <a:effectLst/>
+                <a:latin typeface="+mn-lt"/>
+                <a:ea typeface="+mn-ea"/>
+                <a:cs typeface="+mn-cs"/>
+                <a:sym typeface="Times New Roman"/>
+              </a:rPr>
+              <a:t> </a:t>
+            </a:r>
+            <a:r>
+              <a:rPr lang="pl-PL" sz="2800" i="1" dirty="0" err="1">
+                <a:effectLst/>
+                <a:latin typeface="+mn-lt"/>
+                <a:ea typeface="+mn-ea"/>
+                <a:cs typeface="+mn-cs"/>
+                <a:sym typeface="Times New Roman"/>
+              </a:rPr>
+              <a:t>features</a:t>
+            </a:r>
+            <a:r>
+              <a:rPr lang="pl-PL" sz="2800" dirty="0">
+                <a:effectLst/>
+                <a:latin typeface="+mn-lt"/>
+                <a:ea typeface="+mn-ea"/>
+                <a:cs typeface="+mn-cs"/>
+                <a:sym typeface="Times New Roman"/>
+              </a:rPr>
+              <a:t>). </a:t>
+            </a:r>
+          </a:p>
+          <a:p>
+            <a:pPr lvl="0"/>
+            <a:r>
+              <a:rPr lang="pl-PL" sz="2800" b="1" dirty="0" err="1">
+                <a:effectLst/>
+                <a:latin typeface="+mn-lt"/>
+                <a:ea typeface="+mn-ea"/>
+                <a:cs typeface="+mn-cs"/>
+                <a:sym typeface="Times New Roman"/>
+              </a:rPr>
+              <a:t>Tight</a:t>
+            </a:r>
+            <a:r>
+              <a:rPr lang="pl-PL" sz="2800" b="1" dirty="0">
+                <a:effectLst/>
+                <a:latin typeface="+mn-lt"/>
+                <a:ea typeface="+mn-ea"/>
+                <a:cs typeface="+mn-cs"/>
+                <a:sym typeface="Times New Roman"/>
+              </a:rPr>
+              <a:t> </a:t>
+            </a:r>
+            <a:r>
+              <a:rPr lang="pl-PL" sz="2800" b="1" dirty="0" err="1">
+                <a:effectLst/>
+                <a:latin typeface="+mn-lt"/>
+                <a:ea typeface="+mn-ea"/>
+                <a:cs typeface="+mn-cs"/>
+                <a:sym typeface="Times New Roman"/>
+              </a:rPr>
+              <a:t>feature</a:t>
+            </a:r>
+            <a:r>
+              <a:rPr lang="pl-PL" sz="2800" b="1" dirty="0">
+                <a:effectLst/>
+                <a:latin typeface="+mn-lt"/>
+                <a:ea typeface="+mn-ea"/>
+                <a:cs typeface="+mn-cs"/>
+                <a:sym typeface="Times New Roman"/>
+              </a:rPr>
+              <a:t> </a:t>
+            </a:r>
+            <a:r>
+              <a:rPr lang="pl-PL" sz="2800" b="1" dirty="0" err="1">
+                <a:effectLst/>
+                <a:latin typeface="+mn-lt"/>
+                <a:ea typeface="+mn-ea"/>
+                <a:cs typeface="+mn-cs"/>
+                <a:sym typeface="Times New Roman"/>
+              </a:rPr>
+              <a:t>fusion</a:t>
+            </a:r>
+            <a:r>
+              <a:rPr lang="pl-PL" sz="2800" b="1" dirty="0">
+                <a:effectLst/>
+                <a:latin typeface="+mn-lt"/>
+                <a:ea typeface="+mn-ea"/>
+                <a:cs typeface="+mn-cs"/>
+                <a:sym typeface="Times New Roman"/>
+              </a:rPr>
+              <a:t> (Ścisła fuzja cech):</a:t>
+            </a:r>
+            <a:r>
+              <a:rPr lang="pl-PL" sz="2800" dirty="0">
+                <a:effectLst/>
+                <a:latin typeface="+mn-lt"/>
+                <a:ea typeface="+mn-ea"/>
+                <a:cs typeface="+mn-cs"/>
+                <a:sym typeface="Times New Roman"/>
+              </a:rPr>
+              <a:t> Trzystopniowa integracja modalności wizualnej i tekstowej wewnątrz sieci: </a:t>
+            </a:r>
+          </a:p>
+          <a:p>
+            <a:pPr lvl="1"/>
+            <a:r>
+              <a:rPr lang="pl-PL" sz="2800" dirty="0">
+                <a:effectLst/>
+                <a:latin typeface="+mn-lt"/>
+                <a:ea typeface="+mn-ea"/>
+                <a:cs typeface="+mn-cs"/>
+                <a:sym typeface="Times New Roman"/>
+              </a:rPr>
+              <a:t>W koderze/szyjce (</a:t>
+            </a:r>
+            <a:r>
+              <a:rPr lang="pl-PL" sz="2800" b="1" dirty="0" err="1">
+                <a:effectLst/>
+                <a:latin typeface="+mn-lt"/>
+                <a:ea typeface="+mn-ea"/>
+                <a:cs typeface="+mn-cs"/>
+                <a:sym typeface="Times New Roman"/>
+              </a:rPr>
+              <a:t>Feature</a:t>
+            </a:r>
+            <a:r>
+              <a:rPr lang="pl-PL" sz="2800" b="1" dirty="0">
+                <a:effectLst/>
+                <a:latin typeface="+mn-lt"/>
+                <a:ea typeface="+mn-ea"/>
+                <a:cs typeface="+mn-cs"/>
+                <a:sym typeface="Times New Roman"/>
+              </a:rPr>
+              <a:t> </a:t>
+            </a:r>
+            <a:r>
+              <a:rPr lang="pl-PL" sz="2800" b="1" dirty="0" err="1">
+                <a:effectLst/>
+                <a:latin typeface="+mn-lt"/>
+                <a:ea typeface="+mn-ea"/>
+                <a:cs typeface="+mn-cs"/>
+                <a:sym typeface="Times New Roman"/>
+              </a:rPr>
+              <a:t>Enhancer</a:t>
+            </a:r>
+            <a:r>
+              <a:rPr lang="pl-PL" sz="2800" dirty="0">
+                <a:effectLst/>
+                <a:latin typeface="+mn-lt"/>
+                <a:ea typeface="+mn-ea"/>
+                <a:cs typeface="+mn-cs"/>
+                <a:sym typeface="Times New Roman"/>
+              </a:rPr>
+              <a:t>), </a:t>
+            </a:r>
+          </a:p>
+          <a:p>
+            <a:pPr lvl="1"/>
+            <a:r>
+              <a:rPr lang="pl-PL" sz="2800" dirty="0">
+                <a:effectLst/>
+                <a:latin typeface="+mn-lt"/>
+                <a:ea typeface="+mn-ea"/>
+                <a:cs typeface="+mn-cs"/>
+                <a:sym typeface="Times New Roman"/>
+              </a:rPr>
+              <a:t>Przy inicjalizacji zapytań (</a:t>
+            </a:r>
+            <a:r>
+              <a:rPr lang="pl-PL" sz="2800" b="1" dirty="0">
+                <a:effectLst/>
+                <a:latin typeface="+mn-lt"/>
+                <a:ea typeface="+mn-ea"/>
+                <a:cs typeface="+mn-cs"/>
+                <a:sym typeface="Times New Roman"/>
+              </a:rPr>
+              <a:t>Language-</a:t>
+            </a:r>
+            <a:r>
+              <a:rPr lang="pl-PL" sz="2800" b="1" dirty="0" err="1">
+                <a:effectLst/>
+                <a:latin typeface="+mn-lt"/>
+                <a:ea typeface="+mn-ea"/>
+                <a:cs typeface="+mn-cs"/>
+                <a:sym typeface="Times New Roman"/>
+              </a:rPr>
+              <a:t>Guided</a:t>
+            </a:r>
+            <a:r>
+              <a:rPr lang="pl-PL" sz="2800" b="1" dirty="0">
+                <a:effectLst/>
+                <a:latin typeface="+mn-lt"/>
+                <a:ea typeface="+mn-ea"/>
+                <a:cs typeface="+mn-cs"/>
+                <a:sym typeface="Times New Roman"/>
+              </a:rPr>
+              <a:t> Query </a:t>
+            </a:r>
+            <a:r>
+              <a:rPr lang="pl-PL" sz="2800" b="1" dirty="0" err="1">
+                <a:effectLst/>
+                <a:latin typeface="+mn-lt"/>
+                <a:ea typeface="+mn-ea"/>
+                <a:cs typeface="+mn-cs"/>
+                <a:sym typeface="Times New Roman"/>
+              </a:rPr>
+              <a:t>Selection</a:t>
+            </a:r>
+            <a:r>
+              <a:rPr lang="pl-PL" sz="2800" dirty="0">
+                <a:effectLst/>
+                <a:latin typeface="+mn-lt"/>
+                <a:ea typeface="+mn-ea"/>
+                <a:cs typeface="+mn-cs"/>
+                <a:sym typeface="Times New Roman"/>
+              </a:rPr>
+              <a:t>), </a:t>
+            </a:r>
+          </a:p>
+          <a:p>
+            <a:pPr lvl="1"/>
+            <a:r>
+              <a:rPr lang="pl-PL" sz="2800" dirty="0">
+                <a:effectLst/>
+                <a:latin typeface="+mn-lt"/>
+                <a:ea typeface="+mn-ea"/>
+                <a:cs typeface="+mn-cs"/>
+                <a:sym typeface="Times New Roman"/>
+              </a:rPr>
+              <a:t>W dekoderze (</a:t>
+            </a:r>
+            <a:r>
+              <a:rPr lang="pl-PL" sz="2800" b="1" dirty="0">
+                <a:effectLst/>
+                <a:latin typeface="+mn-lt"/>
+                <a:ea typeface="+mn-ea"/>
+                <a:cs typeface="+mn-cs"/>
+                <a:sym typeface="Times New Roman"/>
+              </a:rPr>
+              <a:t>Cross-</a:t>
+            </a:r>
+            <a:r>
+              <a:rPr lang="pl-PL" sz="2800" b="1" dirty="0" err="1">
+                <a:effectLst/>
+                <a:latin typeface="+mn-lt"/>
+                <a:ea typeface="+mn-ea"/>
+                <a:cs typeface="+mn-cs"/>
+                <a:sym typeface="Times New Roman"/>
+              </a:rPr>
+              <a:t>Modality</a:t>
+            </a:r>
+            <a:r>
+              <a:rPr lang="pl-PL" sz="2800" b="1" dirty="0">
+                <a:effectLst/>
+                <a:latin typeface="+mn-lt"/>
+                <a:ea typeface="+mn-ea"/>
+                <a:cs typeface="+mn-cs"/>
+                <a:sym typeface="Times New Roman"/>
+              </a:rPr>
+              <a:t> </a:t>
+            </a:r>
+            <a:r>
+              <a:rPr lang="pl-PL" sz="2800" b="1" dirty="0" err="1">
+                <a:effectLst/>
+                <a:latin typeface="+mn-lt"/>
+                <a:ea typeface="+mn-ea"/>
+                <a:cs typeface="+mn-cs"/>
+                <a:sym typeface="Times New Roman"/>
+              </a:rPr>
+              <a:t>Decoder</a:t>
+            </a:r>
+            <a:r>
+              <a:rPr lang="pl-PL" sz="2800" dirty="0">
+                <a:effectLst/>
+                <a:latin typeface="+mn-lt"/>
+                <a:ea typeface="+mn-ea"/>
+                <a:cs typeface="+mn-cs"/>
+                <a:sym typeface="Times New Roman"/>
+              </a:rPr>
+              <a:t>). </a:t>
+            </a:r>
+          </a:p>
+          <a:p>
+            <a:pPr lvl="1"/>
+            <a:r>
+              <a:rPr lang="pl-PL" sz="2800" dirty="0">
+                <a:effectLst/>
+                <a:latin typeface="+mn-lt"/>
+                <a:ea typeface="+mn-ea"/>
+                <a:cs typeface="+mn-cs"/>
+                <a:sym typeface="Times New Roman"/>
+              </a:rPr>
+              <a:t>Wcześniejsze modele łączyły tekst z obrazem tylko na jednym etapie (np. GLIP tylko w szyjce, a OV-DETR tylko w zapytaniach). </a:t>
+            </a:r>
+          </a:p>
+          <a:p>
+            <a:pPr lvl="0"/>
+            <a:r>
+              <a:rPr lang="pl-PL" sz="2800" b="1" dirty="0">
+                <a:effectLst/>
+                <a:latin typeface="+mn-lt"/>
+                <a:ea typeface="+mn-ea"/>
+                <a:cs typeface="+mn-cs"/>
+                <a:sym typeface="Times New Roman"/>
+              </a:rPr>
+              <a:t>Language-</a:t>
+            </a:r>
+            <a:r>
+              <a:rPr lang="pl-PL" sz="2800" b="1" dirty="0" err="1">
+                <a:effectLst/>
+                <a:latin typeface="+mn-lt"/>
+                <a:ea typeface="+mn-ea"/>
+                <a:cs typeface="+mn-cs"/>
+                <a:sym typeface="Times New Roman"/>
+              </a:rPr>
+              <a:t>Guided</a:t>
+            </a:r>
+            <a:r>
+              <a:rPr lang="pl-PL" sz="2800" b="1" dirty="0">
+                <a:effectLst/>
+                <a:latin typeface="+mn-lt"/>
+                <a:ea typeface="+mn-ea"/>
+                <a:cs typeface="+mn-cs"/>
+                <a:sym typeface="Times New Roman"/>
+              </a:rPr>
+              <a:t> Query </a:t>
+            </a:r>
+            <a:r>
+              <a:rPr lang="pl-PL" sz="2800" b="1" dirty="0" err="1">
+                <a:effectLst/>
+                <a:latin typeface="+mn-lt"/>
+                <a:ea typeface="+mn-ea"/>
+                <a:cs typeface="+mn-cs"/>
+                <a:sym typeface="Times New Roman"/>
+              </a:rPr>
+              <a:t>Selection</a:t>
+            </a:r>
+            <a:r>
+              <a:rPr lang="pl-PL" sz="2800" b="1" dirty="0">
+                <a:effectLst/>
+                <a:latin typeface="+mn-lt"/>
+                <a:ea typeface="+mn-ea"/>
+                <a:cs typeface="+mn-cs"/>
+                <a:sym typeface="Times New Roman"/>
+              </a:rPr>
+              <a:t> (Wybór zapytań sterowany językiem):</a:t>
+            </a:r>
+            <a:r>
+              <a:rPr lang="pl-PL" sz="2800" dirty="0">
+                <a:effectLst/>
+                <a:latin typeface="+mn-lt"/>
+                <a:ea typeface="+mn-ea"/>
+                <a:cs typeface="+mn-cs"/>
+                <a:sym typeface="Times New Roman"/>
+              </a:rPr>
+              <a:t> Mechanizm dynamicznego wybierania regionów z mapy cech obrazu, które stają się zapytaniami (</a:t>
+            </a:r>
+            <a:r>
+              <a:rPr lang="pl-PL" sz="2800" i="1" dirty="0" err="1">
+                <a:effectLst/>
+                <a:latin typeface="+mn-lt"/>
+                <a:ea typeface="+mn-ea"/>
+                <a:cs typeface="+mn-cs"/>
+                <a:sym typeface="Times New Roman"/>
+              </a:rPr>
+              <a:t>object</a:t>
+            </a:r>
+            <a:r>
+              <a:rPr lang="pl-PL" sz="2800" i="1" dirty="0">
+                <a:effectLst/>
+                <a:latin typeface="+mn-lt"/>
+                <a:ea typeface="+mn-ea"/>
+                <a:cs typeface="+mn-cs"/>
+                <a:sym typeface="Times New Roman"/>
+              </a:rPr>
+              <a:t> </a:t>
+            </a:r>
+            <a:r>
+              <a:rPr lang="pl-PL" sz="2800" i="1" dirty="0" err="1">
+                <a:effectLst/>
+                <a:latin typeface="+mn-lt"/>
+                <a:ea typeface="+mn-ea"/>
+                <a:cs typeface="+mn-cs"/>
+                <a:sym typeface="Times New Roman"/>
+              </a:rPr>
+              <a:t>queries</a:t>
+            </a:r>
+            <a:r>
+              <a:rPr lang="pl-PL" sz="2800" dirty="0">
+                <a:effectLst/>
+                <a:latin typeface="+mn-lt"/>
+                <a:ea typeface="+mn-ea"/>
+                <a:cs typeface="+mn-cs"/>
+                <a:sym typeface="Times New Roman"/>
+              </a:rPr>
+              <a:t>) przekazywanymi do dekodera. Zamiast losowych lub statycznych zapytań, model oblicza iloczyn skalarny cech obrazu i tekstu i wybiera te punkty w obrazie (domyślnie 900), które wykazują </a:t>
+            </a:r>
+            <a:r>
+              <a:rPr lang="pl-PL" sz="2800" b="1" dirty="0">
+                <a:effectLst/>
+                <a:latin typeface="+mn-lt"/>
+                <a:ea typeface="+mn-ea"/>
+                <a:cs typeface="+mn-cs"/>
+                <a:sym typeface="Times New Roman"/>
+              </a:rPr>
+              <a:t>najwyższe prawdopodobieństwo powiązania z wpisanym </a:t>
+            </a:r>
+            <a:r>
+              <a:rPr lang="pl-PL" sz="2800" b="1" dirty="0" err="1">
+                <a:effectLst/>
+                <a:latin typeface="+mn-lt"/>
+                <a:ea typeface="+mn-ea"/>
+                <a:cs typeface="+mn-cs"/>
+                <a:sym typeface="Times New Roman"/>
+              </a:rPr>
+              <a:t>promptem</a:t>
+            </a:r>
+            <a:r>
+              <a:rPr lang="pl-PL" sz="2800" dirty="0">
+                <a:effectLst/>
+                <a:latin typeface="+mn-lt"/>
+                <a:ea typeface="+mn-ea"/>
+                <a:cs typeface="+mn-cs"/>
+                <a:sym typeface="Times New Roman"/>
+              </a:rPr>
+              <a:t>. </a:t>
+            </a:r>
+          </a:p>
+          <a:p>
+            <a:endParaRPr lang="pl-PL" dirty="0"/>
+          </a:p>
+        </p:txBody>
+      </p:sp>
+    </p:spTree>
+    <p:extLst>
+      <p:ext uri="{BB962C8B-B14F-4D97-AF65-F5344CB8AC3E}">
+        <p14:creationId xmlns:p14="http://schemas.microsoft.com/office/powerpoint/2010/main" val="396922316"/>
+      </p:ext>
+    </p:extLst>
+  </p:cSld>
+  <p:clrMapOvr>
+    <a:masterClrMapping/>
+  </p:clrMapOvr>
+</p:notes>
+</file>
+
+<file path=ppt/notesSlides/notesSlide2.xml><?xml version="1.0" encoding="utf-8"?>
+<p:notes xmlns:a="http://schemas.openxmlformats.org/drawingml/2006/main" xmlns:r="http://schemas.openxmlformats.org/officeDocument/2006/relationships" xmlns:p="http://schemas.openxmlformats.org/presentationml/2006/main">
+  <p:cSld>
+    <p:spTree>
+      <p:nvGrpSpPr>
+        <p:cNvPr id="1" name=""/>
+        <p:cNvGrpSpPr/>
+        <p:nvPr/>
+      </p:nvGrpSpPr>
+      <p:grpSpPr>
+        <a:xfrm>
+          <a:off x="0" y="0"/>
+          <a:ext cx="0" cy="0"/>
+          <a:chOff x="0" y="0"/>
+          <a:chExt cx="0" cy="0"/>
+        </a:xfrm>
+      </p:grpSpPr>
+      <p:sp>
+        <p:nvSpPr>
+          <p:cNvPr id="2" name="Symbol zastępczy obrazu slajdu 1"/>
+          <p:cNvSpPr>
+            <a:spLocks noGrp="1" noRot="1" noChangeAspect="1"/>
+          </p:cNvSpPr>
+          <p:nvPr>
+            <p:ph type="sldImg"/>
+          </p:nvPr>
+        </p:nvSpPr>
+        <p:spPr>
+          <a:xfrm>
+            <a:off x="381000" y="685800"/>
+            <a:ext cx="6096000" cy="3429000"/>
+          </a:xfrm>
+        </p:spPr>
+      </p:sp>
+      <p:sp>
+        <p:nvSpPr>
+          <p:cNvPr id="3" name="Symbol zastępczy notatek 2"/>
+          <p:cNvSpPr>
+            <a:spLocks noGrp="1"/>
+          </p:cNvSpPr>
+          <p:nvPr>
+            <p:ph type="body" idx="1"/>
+          </p:nvPr>
+        </p:nvSpPr>
+        <p:spPr/>
+        <p:txBody>
+          <a:bodyPr/>
+          <a:lstStyle/>
+          <a:p>
+            <a:r>
+              <a:rPr lang="pl-PL" sz="2800" dirty="0">
+                <a:effectLst/>
+                <a:latin typeface="+mn-lt"/>
+                <a:ea typeface="+mn-ea"/>
+                <a:cs typeface="+mn-cs"/>
+                <a:sym typeface="Times New Roman"/>
+              </a:rPr>
+              <a:t>„Główną siłą architektury Grounding DINO jest schemat </a:t>
+            </a:r>
+            <a:r>
+              <a:rPr lang="pl-PL" sz="2800" i="1" dirty="0">
+                <a:effectLst/>
+                <a:latin typeface="+mn-lt"/>
+                <a:ea typeface="+mn-ea"/>
+                <a:cs typeface="+mn-cs"/>
+                <a:sym typeface="Times New Roman"/>
+              </a:rPr>
+              <a:t>dual-</a:t>
+            </a:r>
+            <a:r>
+              <a:rPr lang="pl-PL" sz="2800" i="1" dirty="0" err="1">
+                <a:effectLst/>
+                <a:latin typeface="+mn-lt"/>
+                <a:ea typeface="+mn-ea"/>
+                <a:cs typeface="+mn-cs"/>
+                <a:sym typeface="Times New Roman"/>
+              </a:rPr>
+              <a:t>encoder</a:t>
+            </a:r>
+            <a:r>
+              <a:rPr lang="pl-PL" sz="2800" i="1" dirty="0">
+                <a:effectLst/>
+                <a:latin typeface="+mn-lt"/>
+                <a:ea typeface="+mn-ea"/>
+                <a:cs typeface="+mn-cs"/>
+                <a:sym typeface="Times New Roman"/>
+              </a:rPr>
+              <a:t> single-</a:t>
+            </a:r>
+            <a:r>
+              <a:rPr lang="pl-PL" sz="2800" i="1" dirty="0" err="1">
+                <a:effectLst/>
+                <a:latin typeface="+mn-lt"/>
+                <a:ea typeface="+mn-ea"/>
+                <a:cs typeface="+mn-cs"/>
+                <a:sym typeface="Times New Roman"/>
+              </a:rPr>
+              <a:t>decoder</a:t>
+            </a:r>
+            <a:r>
+              <a:rPr lang="pl-PL" sz="2800" dirty="0">
+                <a:effectLst/>
+                <a:latin typeface="+mn-lt"/>
+                <a:ea typeface="+mn-ea"/>
+                <a:cs typeface="+mn-cs"/>
+                <a:sym typeface="Times New Roman"/>
+              </a:rPr>
+              <a:t> z trzystopniową, głęboką fuzją modalności. Zamiast łączyć obraz z tekstem tylko raz, interakcja zachodzi na każdym z trzech poziomów: </a:t>
+            </a:r>
+          </a:p>
+          <a:p>
+            <a:pPr lvl="0"/>
+            <a:r>
+              <a:rPr lang="pl-PL" sz="2800" dirty="0">
+                <a:effectLst/>
+                <a:latin typeface="+mn-lt"/>
+                <a:ea typeface="+mn-ea"/>
+                <a:cs typeface="+mn-cs"/>
+                <a:sym typeface="Times New Roman"/>
+              </a:rPr>
+              <a:t>W module </a:t>
+            </a:r>
+            <a:r>
+              <a:rPr lang="pl-PL" sz="2800" b="1" dirty="0" err="1">
+                <a:effectLst/>
+                <a:latin typeface="+mn-lt"/>
+                <a:ea typeface="+mn-ea"/>
+                <a:cs typeface="+mn-cs"/>
+                <a:sym typeface="Times New Roman"/>
+              </a:rPr>
+              <a:t>Feature</a:t>
+            </a:r>
+            <a:r>
+              <a:rPr lang="pl-PL" sz="2800" b="1" dirty="0">
+                <a:effectLst/>
+                <a:latin typeface="+mn-lt"/>
+                <a:ea typeface="+mn-ea"/>
+                <a:cs typeface="+mn-cs"/>
+                <a:sym typeface="Times New Roman"/>
+              </a:rPr>
+              <a:t> </a:t>
+            </a:r>
+            <a:r>
+              <a:rPr lang="pl-PL" sz="2800" b="1" dirty="0" err="1">
+                <a:effectLst/>
+                <a:latin typeface="+mn-lt"/>
+                <a:ea typeface="+mn-ea"/>
+                <a:cs typeface="+mn-cs"/>
+                <a:sym typeface="Times New Roman"/>
+              </a:rPr>
+              <a:t>Enhancer</a:t>
+            </a:r>
+            <a:r>
+              <a:rPr lang="pl-PL" sz="2800" dirty="0">
+                <a:effectLst/>
+                <a:latin typeface="+mn-lt"/>
+                <a:ea typeface="+mn-ea"/>
+                <a:cs typeface="+mn-cs"/>
+                <a:sym typeface="Times New Roman"/>
+              </a:rPr>
+              <a:t>, gdzie warstwy cross-</a:t>
+            </a:r>
+            <a:r>
+              <a:rPr lang="pl-PL" sz="2800" dirty="0" err="1">
+                <a:effectLst/>
+                <a:latin typeface="+mn-lt"/>
+                <a:ea typeface="+mn-ea"/>
+                <a:cs typeface="+mn-cs"/>
+                <a:sym typeface="Times New Roman"/>
+              </a:rPr>
+              <a:t>attention</a:t>
+            </a:r>
+            <a:r>
+              <a:rPr lang="pl-PL" sz="2800" dirty="0">
+                <a:effectLst/>
+                <a:latin typeface="+mn-lt"/>
+                <a:ea typeface="+mn-ea"/>
+                <a:cs typeface="+mn-cs"/>
+                <a:sym typeface="Times New Roman"/>
+              </a:rPr>
+              <a:t> nieustannie wymieniają informacje między cechami wizualnymi a wektorami tekstu. </a:t>
+            </a:r>
+          </a:p>
+          <a:p>
+            <a:pPr lvl="0"/>
+            <a:r>
+              <a:rPr lang="pl-PL" sz="2800" dirty="0">
+                <a:effectLst/>
+                <a:latin typeface="+mn-lt"/>
+                <a:ea typeface="+mn-ea"/>
+                <a:cs typeface="+mn-cs"/>
+                <a:sym typeface="Times New Roman"/>
+              </a:rPr>
+              <a:t>Na etapie </a:t>
+            </a:r>
+            <a:r>
+              <a:rPr lang="pl-PL" sz="2800" b="1" dirty="0">
+                <a:effectLst/>
+                <a:latin typeface="+mn-lt"/>
+                <a:ea typeface="+mn-ea"/>
+                <a:cs typeface="+mn-cs"/>
+                <a:sym typeface="Times New Roman"/>
+              </a:rPr>
+              <a:t>Query </a:t>
+            </a:r>
+            <a:r>
+              <a:rPr lang="pl-PL" sz="2800" b="1" dirty="0" err="1">
+                <a:effectLst/>
+                <a:latin typeface="+mn-lt"/>
+                <a:ea typeface="+mn-ea"/>
+                <a:cs typeface="+mn-cs"/>
+                <a:sym typeface="Times New Roman"/>
+              </a:rPr>
+              <a:t>Selection</a:t>
+            </a:r>
+            <a:r>
+              <a:rPr lang="pl-PL" sz="2800" dirty="0">
+                <a:effectLst/>
+                <a:latin typeface="+mn-lt"/>
+                <a:ea typeface="+mn-ea"/>
+                <a:cs typeface="+mn-cs"/>
+                <a:sym typeface="Times New Roman"/>
+              </a:rPr>
+              <a:t>, gdzie kwerendy obiektowe do dekodera nie są losowe, lecz wyznaczane przez regiony obrazu najlepiej pasujące semantycznie do wpisanego tekstu. </a:t>
+            </a:r>
+          </a:p>
+          <a:p>
+            <a:pPr lvl="0"/>
+            <a:r>
+              <a:rPr lang="pl-PL" sz="2800" dirty="0">
+                <a:effectLst/>
+                <a:latin typeface="+mn-lt"/>
+                <a:ea typeface="+mn-ea"/>
+                <a:cs typeface="+mn-cs"/>
+                <a:sym typeface="Times New Roman"/>
+              </a:rPr>
+              <a:t>Wreszcie w </a:t>
+            </a:r>
+            <a:r>
+              <a:rPr lang="pl-PL" sz="2800" b="1" dirty="0">
+                <a:effectLst/>
+                <a:latin typeface="+mn-lt"/>
+                <a:ea typeface="+mn-ea"/>
+                <a:cs typeface="+mn-cs"/>
+                <a:sym typeface="Times New Roman"/>
+              </a:rPr>
+              <a:t>dekoderze</a:t>
+            </a:r>
+            <a:r>
+              <a:rPr lang="pl-PL" sz="2800" dirty="0">
+                <a:effectLst/>
+                <a:latin typeface="+mn-lt"/>
+                <a:ea typeface="+mn-ea"/>
+                <a:cs typeface="+mn-cs"/>
+                <a:sym typeface="Times New Roman"/>
+              </a:rPr>
+              <a:t>, w którym każda warstwa posiada dodatkową atencję krzyżową do tekstu, stale pilnując dopasowania wykrywanych obiektów do </a:t>
+            </a:r>
+            <a:r>
+              <a:rPr lang="pl-PL" sz="2800" dirty="0" err="1">
+                <a:effectLst/>
+                <a:latin typeface="+mn-lt"/>
+                <a:ea typeface="+mn-ea"/>
+                <a:cs typeface="+mn-cs"/>
+                <a:sym typeface="Times New Roman"/>
+              </a:rPr>
+              <a:t>promptu</a:t>
+            </a:r>
+            <a:r>
+              <a:rPr lang="pl-PL" sz="2800" dirty="0">
+                <a:effectLst/>
+                <a:latin typeface="+mn-lt"/>
+                <a:ea typeface="+mn-ea"/>
+                <a:cs typeface="+mn-cs"/>
+                <a:sym typeface="Times New Roman"/>
+              </a:rPr>
+              <a:t>.”</a:t>
+            </a:r>
+          </a:p>
+          <a:p>
+            <a:endParaRPr lang="pl-PL" dirty="0"/>
+          </a:p>
+        </p:txBody>
+      </p:sp>
+    </p:spTree>
+    <p:extLst>
+      <p:ext uri="{BB962C8B-B14F-4D97-AF65-F5344CB8AC3E}">
+        <p14:creationId xmlns:p14="http://schemas.microsoft.com/office/powerpoint/2010/main" val="102802192"/>
+      </p:ext>
+    </p:extLst>
+  </p:cSld>
+  <p:clrMapOvr>
+    <a:masterClrMapping/>
+  </p:clrMapOvr>
+</p:notes>
+</file>
+
 <file path=ppt/slideLayouts/slideLayout1.xml><?xml version="1.0" encoding="utf-8"?>
 <p:sldLayout xmlns:a="http://schemas.openxmlformats.org/drawingml/2006/main" xmlns:r="http://schemas.openxmlformats.org/officeDocument/2006/relationships" xmlns:p="http://schemas.openxmlformats.org/presentationml/2006/main" showMasterSp="0" type="tx">
   <p:cSld name="Default">
@@ -1279,7 +2559,7 @@
           </a:ln>
           <a:extLst>
             <a:ext uri="{C572A759-6A51-4108-AA02-DFA0A04FC94B}">
-              <ma14:wrappingTextBoxFlag xmlns:ma14="http://schemas.microsoft.com/office/mac/drawingml/2011/main" xmlns="" val="1"/>
+              <ma14:wrappingTextBoxFlag xmlns="" xmlns:ma14="http://schemas.microsoft.com/office/mac/drawingml/2011/main" val="1"/>
             </a:ext>
           </a:extLst>
         </p:spPr>
@@ -1318,7 +2598,7 @@
           </a:ln>
           <a:extLst>
             <a:ext uri="{C572A759-6A51-4108-AA02-DFA0A04FC94B}">
-              <ma14:wrappingTextBoxFlag xmlns:ma14="http://schemas.microsoft.com/office/mac/drawingml/2011/main" xmlns="" val="1"/>
+              <ma14:wrappingTextBoxFlag xmlns="" xmlns:ma14="http://schemas.microsoft.com/office/mac/drawingml/2011/main" val="1"/>
             </a:ext>
           </a:extLst>
         </p:spPr>
@@ -2360,7 +3640,7 @@
             </a:ln>
             <a:extLst>
               <a:ext uri="{C572A759-6A51-4108-AA02-DFA0A04FC94B}">
-                <ma14:wrappingTextBoxFlag xmlns:ma14="http://schemas.microsoft.com/office/mac/drawingml/2011/main" xmlns="" val="1"/>
+                <ma14:wrappingTextBoxFlag xmlns="" xmlns:ma14="http://schemas.microsoft.com/office/mac/drawingml/2011/main" val="1"/>
               </a:ext>
             </a:extLst>
           </p:spPr>
@@ -2914,7 +4194,7 @@
           </a:prstGeom>
           <a:extLst>
             <a:ext uri="{C572A759-6A51-4108-AA02-DFA0A04FC94B}">
-              <ma14:wrappingTextBoxFlag xmlns:ma14="http://schemas.microsoft.com/office/mac/drawingml/2011/main" xmlns="" val="1"/>
+              <ma14:wrappingTextBoxFlag xmlns="" xmlns:ma14="http://schemas.microsoft.com/office/mac/drawingml/2011/main" val="1"/>
             </a:ext>
           </a:extLst>
         </p:spPr>
@@ -2949,7 +4229,7 @@
           </a:ln>
           <a:extLst>
             <a:ext uri="{C572A759-6A51-4108-AA02-DFA0A04FC94B}">
-              <ma14:wrappingTextBoxFlag xmlns:ma14="http://schemas.microsoft.com/office/mac/drawingml/2011/main" xmlns="" val="1"/>
+              <ma14:wrappingTextBoxFlag xmlns="" xmlns:ma14="http://schemas.microsoft.com/office/mac/drawingml/2011/main" val="1"/>
             </a:ext>
           </a:extLst>
         </p:spPr>
@@ -3131,7 +4411,7 @@
           </a:prstGeom>
           <a:extLst>
             <a:ext uri="{C572A759-6A51-4108-AA02-DFA0A04FC94B}">
-              <ma14:wrappingTextBoxFlag xmlns:ma14="http://schemas.microsoft.com/office/mac/drawingml/2011/main" xmlns="" val="1"/>
+              <ma14:wrappingTextBoxFlag xmlns="" xmlns:ma14="http://schemas.microsoft.com/office/mac/drawingml/2011/main" val="1"/>
             </a:ext>
           </a:extLst>
         </p:spPr>
@@ -3166,7 +4446,7 @@
           </a:ln>
           <a:extLst>
             <a:ext uri="{C572A759-6A51-4108-AA02-DFA0A04FC94B}">
-              <ma14:wrappingTextBoxFlag xmlns:ma14="http://schemas.microsoft.com/office/mac/drawingml/2011/main" xmlns="" val="1"/>
+              <ma14:wrappingTextBoxFlag xmlns="" xmlns:ma14="http://schemas.microsoft.com/office/mac/drawingml/2011/main" val="1"/>
             </a:ext>
           </a:extLst>
         </p:spPr>
@@ -3271,8 +4551,8 @@
         </p:nvSpPr>
         <p:spPr>
           <a:xfrm>
-            <a:off x="1266825" y="3810000"/>
-            <a:ext cx="15875000" cy="6985000"/>
+            <a:off x="1266824" y="2349500"/>
+            <a:ext cx="15875000" cy="9537700"/>
           </a:xfrm>
           <a:prstGeom prst="rect">
             <a:avLst/>
@@ -3296,8 +4576,94 @@
               </a:defRPr>
             </a:pPr>
             <a:r>
-              <a:rPr lang="pl-PL" dirty="0"/>
-              <a:t>Tutaj należy zaprezentować motywację do podjęcia tematu pracy i wprowadzić komisję do poruszanej tematyki i przedstawić problem którym się zajmujemy w pracy</a:t>
+              <a:rPr lang="pl-PL" sz="3500" i="1" dirty="0">
+                <a:solidFill>
+                  <a:srgbClr val="7896CF"/>
+                </a:solidFill>
+                <a:latin typeface="Adagio_Slab-Regular_italic"/>
+                <a:sym typeface="Adagio_Slab-Regular_italic"/>
+              </a:rPr>
+              <a:t>Grounding DINO łączy architekturę </a:t>
+            </a:r>
+            <a:r>
+              <a:rPr lang="pl-PL" sz="3500" i="1" dirty="0" err="1">
+                <a:solidFill>
+                  <a:srgbClr val="7896CF"/>
+                </a:solidFill>
+                <a:latin typeface="Adagio_Slab-Regular_italic"/>
+                <a:sym typeface="Adagio_Slab-Regular_italic"/>
+              </a:rPr>
+              <a:t>transformerowego</a:t>
+            </a:r>
+            <a:r>
+              <a:rPr lang="pl-PL" sz="3500" i="1" dirty="0">
+                <a:solidFill>
+                  <a:srgbClr val="7896CF"/>
+                </a:solidFill>
+                <a:latin typeface="Adagio_Slab-Regular_italic"/>
+                <a:sym typeface="Adagio_Slab-Regular_italic"/>
+              </a:rPr>
+              <a:t> detektora </a:t>
+            </a:r>
+            <a:r>
+              <a:rPr lang="pl-PL" sz="3500" b="1" i="1" dirty="0">
+                <a:solidFill>
+                  <a:srgbClr val="7896CF"/>
+                </a:solidFill>
+                <a:latin typeface="Adagio_Slab-Regular_italic"/>
+                <a:sym typeface="Adagio_Slab-Regular_italic"/>
+              </a:rPr>
+              <a:t>DINO</a:t>
+            </a:r>
+            <a:r>
+              <a:rPr lang="pl-PL" sz="3500" i="1" dirty="0">
+                <a:solidFill>
+                  <a:srgbClr val="7896CF"/>
+                </a:solidFill>
+                <a:latin typeface="Adagio_Slab-Regular_italic"/>
+                <a:sym typeface="Adagio_Slab-Regular_italic"/>
+              </a:rPr>
+              <a:t> z metodyką </a:t>
+            </a:r>
+            <a:r>
+              <a:rPr lang="pl-PL" sz="3500" b="1" i="1" dirty="0">
+                <a:solidFill>
+                  <a:srgbClr val="7896CF"/>
+                </a:solidFill>
+                <a:latin typeface="Adagio_Slab-Regular_italic"/>
+                <a:sym typeface="Adagio_Slab-Regular_italic"/>
+              </a:rPr>
+              <a:t>GLIP</a:t>
+            </a:r>
+            <a:r>
+              <a:rPr lang="pl-PL" sz="3500" i="1" dirty="0">
+                <a:solidFill>
+                  <a:srgbClr val="7896CF"/>
+                </a:solidFill>
+                <a:latin typeface="Adagio_Slab-Regular_italic"/>
+                <a:sym typeface="Adagio_Slab-Regular_italic"/>
+              </a:rPr>
+              <a:t> w zakresie przeformułowania detekcji na zadanie </a:t>
+            </a:r>
+            <a:r>
+              <a:rPr lang="pl-PL" sz="3500" i="1" dirty="0" err="1">
+                <a:solidFill>
+                  <a:srgbClr val="7896CF"/>
+                </a:solidFill>
+                <a:latin typeface="Adagio_Slab-Regular_italic"/>
+                <a:sym typeface="Adagio_Slab-Regular_italic"/>
+              </a:rPr>
+              <a:t>phrase</a:t>
+            </a:r>
+            <a:r>
+              <a:rPr lang="pl-PL" sz="3500" i="1" dirty="0">
+                <a:solidFill>
+                  <a:srgbClr val="7896CF"/>
+                </a:solidFill>
+                <a:latin typeface="Adagio_Slab-Regular_italic"/>
+                <a:sym typeface="Adagio_Slab-Regular_italic"/>
+              </a:rPr>
+              <a:t> Grounding i rozwiązuje ich wspólne problemy.</a:t>
             </a:r>
           </a:p>
           <a:p>
@@ -3312,7 +4678,7 @@
                 <a:sym typeface="Adagio_Slab-Regular_italic"/>
               </a:defRPr>
             </a:pPr>
-            <a:endParaRPr dirty="0">
+            <a:endParaRPr lang="pl-PL" dirty="0">
               <a:solidFill>
                 <a:srgbClr val="965F77"/>
               </a:solidFill>
@@ -3324,30 +4690,176 @@
           </a:p>
           <a:p>
             <a:pPr>
+              <a:lnSpc>
+                <a:spcPct val="200000"/>
+              </a:lnSpc>
               <a:defRPr sz="3500"/>
             </a:pPr>
             <a:r>
-              <a:rPr dirty="0"/>
-              <a:t>Lorem ipsum lorem ipsum lorem ipsum Lorem ipsum lorem ipsum </a:t>
+              <a:rPr lang="pl-PL" b="1" dirty="0"/>
+              <a:t>Mechanizmy zastosowane w Grounding Dino:</a:t>
             </a:r>
           </a:p>
           <a:p>
-            <a:pPr>
+            <a:pPr marL="1138766" lvl="1" indent="-457200">
+              <a:lnSpc>
+                <a:spcPct val="200000"/>
+              </a:lnSpc>
+              <a:buFont typeface="Arial" panose="020B0604020202020204" pitchFamily="34" charset="0"/>
+              <a:buChar char="•"/>
               <a:defRPr sz="3500"/>
             </a:pPr>
             <a:r>
-              <a:rPr dirty="0"/>
-              <a:t>lorem ipsum  Lorem ipsum lorem ipsum lorem ipsum Lorem ipsum lorem ipsum lorem ipsum Lorem ipsum lorem ipsum lorem ipsum Lorem ipsum lorem </a:t>
-            </a:r>
+              <a:rPr lang="pl-PL" dirty="0"/>
+              <a:t>Open-set </a:t>
+            </a:r>
+            <a:r>
+              <a:rPr lang="pl-PL" dirty="0" err="1"/>
+              <a:t>object</a:t>
+            </a:r>
+            <a:r>
+              <a:rPr lang="pl-PL" dirty="0"/>
+              <a:t> </a:t>
+            </a:r>
+            <a:r>
+              <a:rPr lang="pl-PL" dirty="0" err="1"/>
+              <a:t>detection</a:t>
+            </a:r>
+            <a:endParaRPr lang="pl-PL" dirty="0"/>
           </a:p>
           <a:p>
-            <a:pPr>
+            <a:pPr marL="1138766" lvl="1" indent="-457200">
+              <a:lnSpc>
+                <a:spcPct val="200000"/>
+              </a:lnSpc>
+              <a:buFont typeface="Arial" panose="020B0604020202020204" pitchFamily="34" charset="0"/>
+              <a:buChar char="•"/>
               <a:defRPr sz="3500"/>
             </a:pPr>
             <a:r>
-              <a:rPr dirty="0"/>
-              <a:t>ipsum lorem ipsum Lorem ipsum lorem ipsum lorem ipsum</a:t>
-            </a:r>
+              <a:rPr lang="pl-PL" dirty="0" err="1"/>
+              <a:t>Grounded</a:t>
+            </a:r>
+            <a:r>
+              <a:rPr lang="pl-PL" dirty="0"/>
+              <a:t> </a:t>
+            </a:r>
+            <a:r>
+              <a:rPr lang="pl-PL" dirty="0" err="1"/>
+              <a:t>Pre</a:t>
+            </a:r>
+            <a:r>
+              <a:rPr lang="pl-PL" dirty="0"/>
+              <a:t>-Training</a:t>
+            </a:r>
+          </a:p>
+          <a:p>
+            <a:pPr marL="1138766" lvl="1" indent="-457200">
+              <a:lnSpc>
+                <a:spcPct val="200000"/>
+              </a:lnSpc>
+              <a:buFont typeface="Arial" panose="020B0604020202020204" pitchFamily="34" charset="0"/>
+              <a:buChar char="•"/>
+              <a:defRPr sz="3500"/>
+            </a:pPr>
+            <a:r>
+              <a:rPr lang="pl-PL" dirty="0" err="1"/>
+              <a:t>Sub-sentence</a:t>
+            </a:r>
+            <a:r>
+              <a:rPr lang="pl-PL" dirty="0"/>
+              <a:t> </a:t>
+            </a:r>
+            <a:r>
+              <a:rPr lang="pl-PL" dirty="0" err="1"/>
+              <a:t>text</a:t>
+            </a:r>
+            <a:r>
+              <a:rPr lang="pl-PL" dirty="0"/>
+              <a:t> </a:t>
+            </a:r>
+            <a:r>
+              <a:rPr lang="pl-PL" dirty="0" err="1"/>
+              <a:t>representation</a:t>
+            </a:r>
+            <a:endParaRPr lang="pl-PL" dirty="0"/>
+          </a:p>
+          <a:p>
+            <a:pPr marL="1138766" lvl="1" indent="-457200">
+              <a:lnSpc>
+                <a:spcPct val="200000"/>
+              </a:lnSpc>
+              <a:buFont typeface="Arial" panose="020B0604020202020204" pitchFamily="34" charset="0"/>
+              <a:buChar char="•"/>
+              <a:defRPr sz="3500"/>
+            </a:pPr>
+            <a:r>
+              <a:rPr lang="pl-PL" dirty="0" err="1"/>
+              <a:t>Tight</a:t>
+            </a:r>
+            <a:r>
+              <a:rPr lang="pl-PL" dirty="0"/>
+              <a:t> </a:t>
+            </a:r>
+            <a:r>
+              <a:rPr lang="pl-PL" dirty="0" err="1"/>
+              <a:t>feature</a:t>
+            </a:r>
+            <a:r>
+              <a:rPr lang="pl-PL" dirty="0"/>
+              <a:t> </a:t>
+            </a:r>
+            <a:r>
+              <a:rPr lang="pl-PL" dirty="0" err="1"/>
+              <a:t>fusion</a:t>
+            </a:r>
+            <a:endParaRPr lang="pl-PL" dirty="0"/>
+          </a:p>
+          <a:p>
+            <a:pPr marL="1138766" lvl="1" indent="-457200">
+              <a:lnSpc>
+                <a:spcPct val="200000"/>
+              </a:lnSpc>
+              <a:buFont typeface="Arial" panose="020B0604020202020204" pitchFamily="34" charset="0"/>
+              <a:buChar char="•"/>
+              <a:defRPr sz="3500"/>
+            </a:pPr>
+            <a:r>
+              <a:rPr lang="pl-PL" dirty="0"/>
+              <a:t>Language-</a:t>
+            </a:r>
+            <a:r>
+              <a:rPr lang="pl-PL" dirty="0" err="1"/>
+              <a:t>Guided</a:t>
+            </a:r>
+            <a:r>
+              <a:rPr lang="pl-PL" dirty="0"/>
+              <a:t> Query </a:t>
+            </a:r>
+            <a:r>
+              <a:rPr lang="pl-PL" dirty="0" err="1"/>
+              <a:t>Selection</a:t>
+            </a:r>
+            <a:endParaRPr lang="pl-PL" dirty="0"/>
+          </a:p>
+          <a:p>
+            <a:pPr marL="457200" indent="-457200">
+              <a:lnSpc>
+                <a:spcPct val="200000"/>
+              </a:lnSpc>
+              <a:buFont typeface="Arial" panose="020B0604020202020204" pitchFamily="34" charset="0"/>
+              <a:buChar char="•"/>
+              <a:defRPr sz="3500"/>
+            </a:pPr>
+            <a:endParaRPr lang="pl-PL" dirty="0"/>
+          </a:p>
+          <a:p>
+            <a:pPr marL="457200" indent="-457200">
+              <a:buFont typeface="Arial" panose="020B0604020202020204" pitchFamily="34" charset="0"/>
+              <a:buChar char="•"/>
+              <a:defRPr sz="3500"/>
+            </a:pPr>
+            <a:endParaRPr dirty="0"/>
           </a:p>
         </p:txBody>
       </p:sp>
@@ -3377,7 +4889,7 @@
           </a:prstGeom>
           <a:extLst>
             <a:ext uri="{C572A759-6A51-4108-AA02-DFA0A04FC94B}">
-              <ma14:wrappingTextBoxFlag xmlns="" xmlns:ma14="http://schemas.microsoft.com/office/mac/drawingml/2011/main" val="1"/>
+              <ma14:wrappingTextBoxFlag xmlns:ma14="http://schemas.microsoft.com/office/mac/drawingml/2011/main" xmlns="" val="1"/>
             </a:ext>
           </a:extLst>
         </p:spPr>
@@ -3418,7 +4930,7 @@
           </a:ln>
           <a:extLst>
             <a:ext uri="{C572A759-6A51-4108-AA02-DFA0A04FC94B}">
-              <ma14:wrappingTextBoxFlag xmlns="" xmlns:ma14="http://schemas.microsoft.com/office/mac/drawingml/2011/main" val="1"/>
+              <ma14:wrappingTextBoxFlag xmlns:ma14="http://schemas.microsoft.com/office/mac/drawingml/2011/main" xmlns="" val="1"/>
             </a:ext>
           </a:extLst>
         </p:spPr>
@@ -3448,12 +4960,156 @@
           <a:p>
             <a:r>
               <a:rPr lang="pl-PL" dirty="0"/>
-              <a:t>Ogólna idea</a:t>
+              <a:t>Cechy Grounding </a:t>
+            </a:r>
+            <a:r>
+              <a:rPr lang="pl-PL" dirty="0" err="1"/>
+              <a:t>DINOzar</a:t>
             </a:r>
             <a:endParaRPr dirty="0"/>
           </a:p>
         </p:txBody>
       </p:sp>
+      <p:grpSp>
+        <p:nvGrpSpPr>
+          <p:cNvPr id="5" name="Grupa 4">
+            <a:extLst>
+              <a:ext uri="{FF2B5EF4-FFF2-40B4-BE49-F238E27FC236}">
+                <a16:creationId xmlns:a16="http://schemas.microsoft.com/office/drawing/2014/main" id="{BED7C42D-D589-CD33-674A-E2339F9D2387}"/>
+              </a:ext>
+            </a:extLst>
+          </p:cNvPr>
+          <p:cNvGrpSpPr/>
+          <p:nvPr/>
+        </p:nvGrpSpPr>
+        <p:grpSpPr>
+          <a:xfrm>
+            <a:off x="9754747" y="6560998"/>
+            <a:ext cx="8860279" cy="3339053"/>
+            <a:chOff x="9846821" y="4617898"/>
+            <a:chExt cx="8860279" cy="3339053"/>
+          </a:xfrm>
+        </p:grpSpPr>
+        <p:pic>
+          <p:nvPicPr>
+            <p:cNvPr id="3" name="Obraz 2">
+              <a:extLst>
+                <a:ext uri="{FF2B5EF4-FFF2-40B4-BE49-F238E27FC236}">
+                  <a16:creationId xmlns:a16="http://schemas.microsoft.com/office/drawing/2014/main" id="{B8D710C4-177E-A84D-7EEA-BD1610E69BC2}"/>
+                </a:ext>
+              </a:extLst>
+            </p:cNvPr>
+            <p:cNvPicPr>
+              <a:picLocks noChangeAspect="1"/>
+            </p:cNvPicPr>
+            <p:nvPr/>
+          </p:nvPicPr>
+          <p:blipFill>
+            <a:blip r:embed="rId3"/>
+            <a:stretch>
+              <a:fillRect/>
+            </a:stretch>
+          </p:blipFill>
+          <p:spPr>
+            <a:xfrm>
+              <a:off x="9846821" y="4617898"/>
+              <a:ext cx="8860279" cy="2793060"/>
+            </a:xfrm>
+            <a:prstGeom prst="roundRect">
+              <a:avLst>
+                <a:gd name="adj" fmla="val 10259"/>
+              </a:avLst>
+            </a:prstGeom>
+            <a:ln w="57150">
+              <a:solidFill>
+                <a:srgbClr val="7896CF"/>
+              </a:solidFill>
+            </a:ln>
+          </p:spPr>
+        </p:pic>
+        <p:sp>
+          <p:nvSpPr>
+            <p:cNvPr id="4" name="pole tekstowe 3">
+              <a:extLst>
+                <a:ext uri="{FF2B5EF4-FFF2-40B4-BE49-F238E27FC236}">
+                  <a16:creationId xmlns:a16="http://schemas.microsoft.com/office/drawing/2014/main" id="{11AF2D47-C799-95CB-F25E-26C7D79B0B10}"/>
+                </a:ext>
+              </a:extLst>
+            </p:cNvPr>
+            <p:cNvSpPr txBox="1"/>
+            <p:nvPr/>
+          </p:nvSpPr>
+          <p:spPr>
+            <a:xfrm>
+              <a:off x="12175110" y="7251700"/>
+              <a:ext cx="4325364" cy="705251"/>
+            </a:xfrm>
+            <a:prstGeom prst="rect">
+              <a:avLst/>
+            </a:prstGeom>
+            <a:noFill/>
+            <a:ln w="12700" cap="flat">
+              <a:noFill/>
+              <a:miter lim="400000"/>
+            </a:ln>
+            <a:effectLst/>
+            <a:sp3d/>
+          </p:spPr>
+          <p:style>
+            <a:lnRef idx="0">
+              <a:scrgbClr r="0" g="0" b="0"/>
+            </a:lnRef>
+            <a:fillRef idx="0">
+              <a:scrgbClr r="0" g="0" b="0"/>
+            </a:fillRef>
+            <a:effectRef idx="0">
+              <a:scrgbClr r="0" g="0" b="0"/>
+            </a:effectRef>
+            <a:fontRef idx="none"/>
+          </p:style>
+          <p:txBody>
+            <a:bodyPr rot="0" spcFirstLastPara="1" vertOverflow="overflow" horzOverflow="overflow" vert="horz" wrap="square" lIns="110709" tIns="110709" rIns="110709" bIns="110709" numCol="1" spcCol="38100" rtlCol="0" anchor="t">
+              <a:spAutoFit/>
+            </a:bodyPr>
+            <a:lstStyle/>
+            <a:p>
+              <a:pPr marL="0" marR="0" indent="0" algn="l" defTabSz="1087437" rtl="0" fontAlgn="auto" latinLnBrk="0" hangingPunct="0">
+                <a:lnSpc>
+                  <a:spcPct val="120000"/>
+                </a:lnSpc>
+                <a:spcBef>
+                  <a:spcPts val="300"/>
+                </a:spcBef>
+                <a:spcAft>
+                  <a:spcPts val="0"/>
+                </a:spcAft>
+                <a:buClrTx/>
+                <a:buSzTx/>
+                <a:buFontTx/>
+                <a:buNone/>
+                <a:tabLst/>
+              </a:pPr>
+              <a:r>
+                <a:rPr kumimoji="0" lang="pl-PL" sz="2400" b="0" i="0" u="none" strike="noStrike" cap="none" spc="0" normalizeH="0" baseline="0" dirty="0">
+                  <a:ln>
+                    <a:noFill/>
+                  </a:ln>
+                  <a:solidFill>
+                    <a:schemeClr val="bg2">
+                      <a:lumMod val="75000"/>
+                    </a:schemeClr>
+                  </a:solidFill>
+                  <a:effectLst/>
+                  <a:uFillTx/>
+                  <a:latin typeface="Adagio_Slab"/>
+                  <a:sym typeface="Times New Roman"/>
+                </a:rPr>
+                <a:t>Porównanie reprezentacji tekstu</a:t>
+              </a:r>
+            </a:p>
+          </p:txBody>
+        </p:sp>
+      </p:grpSp>
     </p:spTree>
     <p:extLst>
       <p:ext uri="{BB962C8B-B14F-4D97-AF65-F5344CB8AC3E}">
@@ -3507,8 +5163,8 @@
         </p:nvSpPr>
         <p:spPr>
           <a:xfrm>
-            <a:off x="1266825" y="3810000"/>
-            <a:ext cx="15875000" cy="6985000"/>
+            <a:off x="784224" y="2392855"/>
+            <a:ext cx="8151022" cy="1001813"/>
           </a:xfrm>
           <a:prstGeom prst="rect">
             <a:avLst/>
@@ -3516,7 +5172,7 @@
         </p:spPr>
         <p:txBody>
           <a:bodyPr>
-            <a:normAutofit lnSpcReduction="10000"/>
+            <a:normAutofit/>
           </a:bodyPr>
           <a:lstStyle/>
           <a:p>
@@ -3533,142 +5189,21 @@
             </a:pPr>
             <a:r>
               <a:rPr lang="pl-PL" dirty="0"/>
-              <a:t>Tutaj trzeba sformułować cel główny pracy i zdefiniować cele poboczne.</a:t>
-            </a:r>
-          </a:p>
-          <a:p>
-            <a:pPr>
-              <a:defRPr sz="3500" i="1">
-                <a:solidFill>
-                  <a:srgbClr val="7896CF"/>
-                </a:solidFill>
-                <a:latin typeface="Adagio_Slab-Regular_italic"/>
-                <a:ea typeface="Adagio_Slab-Regular_italic"/>
-                <a:cs typeface="Adagio_Slab-Regular_italic"/>
-                <a:sym typeface="Adagio_Slab-Regular_italic"/>
-              </a:defRPr>
-            </a:pPr>
+              <a:t>Architektura dual-</a:t>
+            </a:r>
+            <a:r>
+              <a:rPr lang="pl-PL" dirty="0" err="1"/>
+              <a:t>encoder</a:t>
+            </a:r>
             <a:r>
               <a:rPr lang="pl-PL" dirty="0"/>
-              <a:t>Cel powinien być:</a:t>
-            </a:r>
-          </a:p>
-          <a:p>
-            <a:pPr>
-              <a:defRPr sz="3500" i="1">
-                <a:solidFill>
-                  <a:srgbClr val="7896CF"/>
-                </a:solidFill>
-                <a:latin typeface="Adagio_Slab-Regular_italic"/>
-                <a:ea typeface="Adagio_Slab-Regular_italic"/>
-                <a:cs typeface="Adagio_Slab-Regular_italic"/>
-                <a:sym typeface="Adagio_Slab-Regular_italic"/>
-              </a:defRPr>
-            </a:pPr>
-            <a:r>
-              <a:rPr lang="pl-PL" dirty="0"/>
-              <a:t>	- zrozumiały</a:t>
-            </a:r>
-          </a:p>
-          <a:p>
-            <a:pPr>
-              <a:defRPr sz="3500" i="1">
-                <a:solidFill>
-                  <a:srgbClr val="7896CF"/>
-                </a:solidFill>
-                <a:latin typeface="Adagio_Slab-Regular_italic"/>
-                <a:ea typeface="Adagio_Slab-Regular_italic"/>
-                <a:cs typeface="Adagio_Slab-Regular_italic"/>
-                <a:sym typeface="Adagio_Slab-Regular_italic"/>
-              </a:defRPr>
-            </a:pPr>
-            <a:r>
-              <a:rPr lang="pl-PL" dirty="0"/>
-              <a:t>	- osiągalny</a:t>
-            </a:r>
-          </a:p>
-          <a:p>
-            <a:pPr>
-              <a:defRPr sz="3500" i="1">
-                <a:solidFill>
-                  <a:srgbClr val="7896CF"/>
-                </a:solidFill>
-                <a:latin typeface="Adagio_Slab-Regular_italic"/>
-                <a:ea typeface="Adagio_Slab-Regular_italic"/>
-                <a:cs typeface="Adagio_Slab-Regular_italic"/>
-                <a:sym typeface="Adagio_Slab-Regular_italic"/>
-              </a:defRPr>
-            </a:pPr>
-            <a:r>
-              <a:rPr lang="pl-PL" dirty="0"/>
-              <a:t>	- mierzalny</a:t>
-            </a:r>
-          </a:p>
-          <a:p>
-            <a:pPr>
-              <a:defRPr sz="3500" i="1">
-                <a:solidFill>
-                  <a:srgbClr val="7896CF"/>
-                </a:solidFill>
-                <a:latin typeface="Adagio_Slab-Regular_italic"/>
-                <a:ea typeface="Adagio_Slab-Regular_italic"/>
-                <a:cs typeface="Adagio_Slab-Regular_italic"/>
-                <a:sym typeface="Adagio_Slab-Regular_italic"/>
-              </a:defRPr>
-            </a:pPr>
-            <a:r>
-              <a:rPr lang="pl-PL" dirty="0"/>
-              <a:t>	- krótko i jasno sformułowany</a:t>
-            </a:r>
-          </a:p>
-          <a:p>
-            <a:pPr>
-              <a:defRPr sz="3500" i="1">
-                <a:solidFill>
-                  <a:srgbClr val="7896CF"/>
-                </a:solidFill>
-                <a:latin typeface="Adagio_Slab-Regular_italic"/>
-                <a:ea typeface="Adagio_Slab-Regular_italic"/>
-                <a:cs typeface="Adagio_Slab-Regular_italic"/>
-                <a:sym typeface="Adagio_Slab-Regular_italic"/>
-              </a:defRPr>
-            </a:pPr>
-            <a:endParaRPr dirty="0">
-              <a:solidFill>
-                <a:srgbClr val="965F77"/>
-              </a:solidFill>
-              <a:latin typeface="+mj-lt"/>
-              <a:ea typeface="+mj-ea"/>
-              <a:cs typeface="+mj-cs"/>
-              <a:sym typeface="Helvetica"/>
-            </a:endParaRPr>
-          </a:p>
-          <a:p>
-            <a:pPr>
-              <a:defRPr sz="3500"/>
-            </a:pPr>
-            <a:r>
-              <a:rPr dirty="0"/>
-              <a:t>Lorem ipsum lorem ipsum lorem ipsum Lorem ipsum lorem ipsum </a:t>
-            </a:r>
-          </a:p>
-          <a:p>
-            <a:pPr>
-              <a:defRPr sz="3500"/>
-            </a:pPr>
-            <a:r>
-              <a:rPr dirty="0"/>
-              <a:t>lorem ipsum  Lorem ipsum lorem ipsum lorem ipsum Lorem ipsum lorem ipsum lorem ipsum Lorem ipsum lorem ipsum lorem ipsum Lorem ipsum lorem </a:t>
-            </a:r>
-          </a:p>
-          <a:p>
-            <a:pPr>
-              <a:defRPr sz="3500"/>
-            </a:pPr>
-            <a:r>
-              <a:rPr dirty="0"/>
-              <a:t>ipsum lorem ipsum Lorem ipsum lorem ipsum lorem ipsum</a:t>
-            </a:r>
+              <a:t> &amp; single-</a:t>
+            </a:r>
+            <a:r>
+              <a:rPr lang="pl-PL" dirty="0" err="1"/>
+              <a:t>decoder</a:t>
+            </a:r>
+            <a:endParaRPr lang="pl-PL" dirty="0"/>
           </a:p>
         </p:txBody>
       </p:sp>
@@ -3692,7 +5227,7 @@
           </a:prstGeom>
           <a:extLst>
             <a:ext uri="{C572A759-6A51-4108-AA02-DFA0A04FC94B}">
-              <ma14:wrappingTextBoxFlag xmlns:ma14="http://schemas.microsoft.com/office/mac/drawingml/2011/main" xmlns="" val="1"/>
+              <ma14:wrappingTextBoxFlag xmlns="" xmlns:ma14="http://schemas.microsoft.com/office/mac/drawingml/2011/main" val="1"/>
             </a:ext>
           </a:extLst>
         </p:spPr>
@@ -3785,7 +5320,7 @@
           </a:ln>
           <a:extLst>
             <a:ext uri="{C572A759-6A51-4108-AA02-DFA0A04FC94B}">
-              <ma14:wrappingTextBoxFlag xmlns:ma14="http://schemas.microsoft.com/office/mac/drawingml/2011/main" xmlns="" val="1"/>
+              <ma14:wrappingTextBoxFlag xmlns="" xmlns:ma14="http://schemas.microsoft.com/office/mac/drawingml/2011/main" val="1"/>
             </a:ext>
           </a:extLst>
         </p:spPr>
@@ -3877,21 +5412,570 @@
           <p:nvPr/>
         </p:nvPicPr>
         <p:blipFill>
-          <a:blip r:embed="rId2"/>
+          <a:blip r:embed="rId3"/>
           <a:stretch>
             <a:fillRect/>
           </a:stretch>
         </p:blipFill>
         <p:spPr>
           <a:xfrm>
-            <a:off x="11689080" y="1114076"/>
-            <a:ext cx="7772400" cy="5391848"/>
+            <a:off x="9410700" y="1757286"/>
+            <a:ext cx="13608846" cy="9440692"/>
+          </a:xfrm>
+          <a:prstGeom prst="roundRect">
+            <a:avLst>
+              <a:gd name="adj" fmla="val 10394"/>
+            </a:avLst>
+          </a:prstGeom>
+          <a:ln w="57150">
+            <a:solidFill>
+              <a:srgbClr val="7896CF"/>
+            </a:solidFill>
+          </a:ln>
+        </p:spPr>
+      </p:pic>
+      <p:sp>
+        <p:nvSpPr>
+          <p:cNvPr id="4" name="pole tekstowe 3">
+            <a:extLst>
+              <a:ext uri="{FF2B5EF4-FFF2-40B4-BE49-F238E27FC236}">
+                <a16:creationId xmlns:a16="http://schemas.microsoft.com/office/drawing/2014/main" id="{927CBD9B-B82D-4042-A9FA-58408183A052}"/>
+              </a:ext>
+            </a:extLst>
+          </p:cNvPr>
+          <p:cNvSpPr txBox="1"/>
+          <p:nvPr/>
+        </p:nvSpPr>
+        <p:spPr>
+          <a:xfrm>
+            <a:off x="291835" y="3750268"/>
+            <a:ext cx="8643411" cy="7108542"/>
           </a:xfrm>
           <a:prstGeom prst="rect">
             <a:avLst/>
           </a:prstGeom>
+          <a:noFill/>
+          <a:ln w="12700" cap="flat">
+            <a:noFill/>
+            <a:miter lim="400000"/>
+          </a:ln>
+          <a:effectLst/>
+          <a:sp3d/>
         </p:spPr>
-      </p:pic>
+        <p:style>
+          <a:lnRef idx="0">
+            <a:scrgbClr r="0" g="0" b="0"/>
+          </a:lnRef>
+          <a:fillRef idx="0">
+            <a:scrgbClr r="0" g="0" b="0"/>
+          </a:fillRef>
+          <a:effectRef idx="0">
+            <a:scrgbClr r="0" g="0" b="0"/>
+          </a:effectRef>
+          <a:fontRef idx="none"/>
+        </p:style>
+        <p:txBody>
+          <a:bodyPr rot="0" spcFirstLastPara="1" vertOverflow="overflow" horzOverflow="overflow" vert="horz" wrap="square" lIns="110709" tIns="110709" rIns="110709" bIns="110709" numCol="1" spcCol="38100" rtlCol="0" anchor="t">
+            <a:spAutoFit/>
+          </a:bodyPr>
+          <a:lstStyle/>
+          <a:p>
+            <a:pPr lvl="0"/>
+            <a:r>
+              <a:rPr lang="pl-PL" sz="3200" b="1" dirty="0">
+                <a:solidFill>
+                  <a:schemeClr val="tx2">
+                    <a:lumMod val="75000"/>
+                  </a:schemeClr>
+                </a:solidFill>
+                <a:latin typeface="Adagio_Slab"/>
+              </a:rPr>
+              <a:t>Ekstrakcja cech</a:t>
+            </a:r>
+            <a:endParaRPr lang="pl-PL" sz="3200" dirty="0">
+              <a:solidFill>
+                <a:schemeClr val="tx2">
+                  <a:lumMod val="75000"/>
+                </a:schemeClr>
+              </a:solidFill>
+              <a:latin typeface="Adagio_Slab"/>
+            </a:endParaRPr>
+          </a:p>
+          <a:p>
+            <a:pPr lvl="3"/>
+            <a:r>
+              <a:rPr lang="pl-PL" sz="3200" b="1" dirty="0">
+                <a:solidFill>
+                  <a:schemeClr val="tx2">
+                    <a:lumMod val="75000"/>
+                  </a:schemeClr>
+                </a:solidFill>
+                <a:latin typeface="Adagio_Slab"/>
+              </a:rPr>
+              <a:t>	Obraz:</a:t>
+            </a:r>
+            <a:r>
+              <a:rPr lang="pl-PL" sz="3200" dirty="0">
+                <a:solidFill>
+                  <a:schemeClr val="tx2">
+                    <a:lumMod val="75000"/>
+                  </a:schemeClr>
+                </a:solidFill>
+                <a:latin typeface="Adagio_Slab"/>
+              </a:rPr>
+              <a:t> </a:t>
+            </a:r>
+            <a:r>
+              <a:rPr lang="pl-PL" sz="3200" i="1" dirty="0" err="1">
+                <a:solidFill>
+                  <a:schemeClr val="tx2">
+                    <a:lumMod val="75000"/>
+                  </a:schemeClr>
+                </a:solidFill>
+                <a:latin typeface="Adagio_Slab"/>
+              </a:rPr>
+              <a:t>Swin</a:t>
+            </a:r>
+            <a:r>
+              <a:rPr lang="pl-PL" sz="3200" i="1" dirty="0">
+                <a:solidFill>
+                  <a:schemeClr val="tx2">
+                    <a:lumMod val="75000"/>
+                  </a:schemeClr>
+                </a:solidFill>
+                <a:latin typeface="Adagio_Slab"/>
+              </a:rPr>
+              <a:t> Transformer</a:t>
+            </a:r>
+            <a:endParaRPr lang="pl-PL" sz="3200" dirty="0">
+              <a:solidFill>
+                <a:schemeClr val="tx2">
+                  <a:lumMod val="75000"/>
+                </a:schemeClr>
+              </a:solidFill>
+              <a:latin typeface="Adagio_Slab"/>
+            </a:endParaRPr>
+          </a:p>
+          <a:p>
+            <a:pPr lvl="3"/>
+            <a:r>
+              <a:rPr lang="pl-PL" sz="3200" b="1" dirty="0">
+                <a:solidFill>
+                  <a:schemeClr val="tx2">
+                    <a:lumMod val="75000"/>
+                  </a:schemeClr>
+                </a:solidFill>
+                <a:latin typeface="Adagio_Slab"/>
+              </a:rPr>
+              <a:t>	Tekst:</a:t>
+            </a:r>
+            <a:r>
+              <a:rPr lang="pl-PL" sz="3200" dirty="0">
+                <a:solidFill>
+                  <a:schemeClr val="tx2">
+                    <a:lumMod val="75000"/>
+                  </a:schemeClr>
+                </a:solidFill>
+                <a:latin typeface="Adagio_Slab"/>
+              </a:rPr>
+              <a:t> </a:t>
+            </a:r>
+            <a:r>
+              <a:rPr lang="pl-PL" sz="3200" i="1" dirty="0">
+                <a:solidFill>
+                  <a:schemeClr val="tx2">
+                    <a:lumMod val="75000"/>
+                  </a:schemeClr>
+                </a:solidFill>
+                <a:latin typeface="Adagio_Slab"/>
+              </a:rPr>
+              <a:t>BERT</a:t>
+            </a:r>
+            <a:endParaRPr lang="pl-PL" sz="3200" dirty="0">
+              <a:solidFill>
+                <a:schemeClr val="tx2">
+                  <a:lumMod val="75000"/>
+                </a:schemeClr>
+              </a:solidFill>
+              <a:latin typeface="Adagio_Slab"/>
+            </a:endParaRPr>
+          </a:p>
+          <a:p>
+            <a:pPr lvl="0"/>
+            <a:r>
+              <a:rPr lang="pl-PL" sz="3200" b="1" dirty="0">
+                <a:solidFill>
+                  <a:schemeClr val="tx2">
+                    <a:lumMod val="75000"/>
+                  </a:schemeClr>
+                </a:solidFill>
+                <a:latin typeface="Adagio_Slab"/>
+              </a:rPr>
+              <a:t>3 Fazy ścisłej fuzji</a:t>
+            </a:r>
+            <a:endParaRPr lang="pl-PL" sz="3200" dirty="0">
+              <a:solidFill>
+                <a:schemeClr val="tx2">
+                  <a:lumMod val="75000"/>
+                </a:schemeClr>
+              </a:solidFill>
+              <a:latin typeface="Adagio_Slab"/>
+            </a:endParaRPr>
+          </a:p>
+          <a:p>
+            <a:pPr lvl="1"/>
+            <a:r>
+              <a:rPr lang="pl-PL" sz="3200" b="1" dirty="0">
+                <a:solidFill>
+                  <a:schemeClr val="tx2">
+                    <a:lumMod val="75000"/>
+                  </a:schemeClr>
+                </a:solidFill>
+                <a:latin typeface="Adagio_Slab"/>
+              </a:rPr>
+              <a:t>	Faza 1 - </a:t>
+            </a:r>
+            <a:r>
+              <a:rPr lang="pl-PL" sz="3200" b="1" i="1" dirty="0" err="1">
+                <a:solidFill>
+                  <a:schemeClr val="tx2">
+                    <a:lumMod val="75000"/>
+                  </a:schemeClr>
+                </a:solidFill>
+                <a:latin typeface="Adagio_Slab"/>
+              </a:rPr>
+              <a:t>Feature</a:t>
+            </a:r>
+            <a:r>
+              <a:rPr lang="pl-PL" sz="3200" b="1" i="1" dirty="0">
+                <a:solidFill>
+                  <a:schemeClr val="tx2">
+                    <a:lumMod val="75000"/>
+                  </a:schemeClr>
+                </a:solidFill>
+                <a:latin typeface="Adagio_Slab"/>
+              </a:rPr>
+              <a:t> </a:t>
+            </a:r>
+            <a:r>
+              <a:rPr lang="pl-PL" sz="3200" b="1" i="1" dirty="0" err="1">
+                <a:solidFill>
+                  <a:schemeClr val="tx2">
+                    <a:lumMod val="75000"/>
+                  </a:schemeClr>
+                </a:solidFill>
+                <a:latin typeface="Adagio_Slab"/>
+              </a:rPr>
+              <a:t>Enhancer</a:t>
+            </a:r>
+            <a:r>
+              <a:rPr lang="pl-PL" sz="3200" b="1" dirty="0">
+                <a:solidFill>
+                  <a:schemeClr val="tx2">
+                    <a:lumMod val="75000"/>
+                  </a:schemeClr>
+                </a:solidFill>
+                <a:latin typeface="Adagio_Slab"/>
+              </a:rPr>
+              <a:t>:</a:t>
+            </a:r>
+            <a:endParaRPr lang="pl-PL" sz="3200" dirty="0">
+              <a:solidFill>
+                <a:schemeClr val="tx2">
+                  <a:lumMod val="75000"/>
+                </a:schemeClr>
+              </a:solidFill>
+              <a:latin typeface="Adagio_Slab"/>
+            </a:endParaRPr>
+          </a:p>
+          <a:p>
+            <a:pPr lvl="3"/>
+            <a:r>
+              <a:rPr lang="pl-PL" sz="3200" dirty="0">
+                <a:solidFill>
+                  <a:schemeClr val="tx2">
+                    <a:lumMod val="75000"/>
+                  </a:schemeClr>
+                </a:solidFill>
+                <a:latin typeface="Adagio_Slab"/>
+              </a:rPr>
+              <a:t>		Dwukierunkowa uwaga krzyżowa</a:t>
+            </a:r>
+          </a:p>
+          <a:p>
+            <a:pPr lvl="3"/>
+            <a:r>
+              <a:rPr lang="pl-PL" sz="3200" b="1" dirty="0">
+                <a:solidFill>
+                  <a:schemeClr val="tx2">
+                    <a:lumMod val="75000"/>
+                  </a:schemeClr>
+                </a:solidFill>
+                <a:latin typeface="Adagio_Slab"/>
+              </a:rPr>
+              <a:t>	Faza 2 - </a:t>
+            </a:r>
+            <a:r>
+              <a:rPr lang="pl-PL" sz="3200" b="1" i="1" dirty="0">
+                <a:solidFill>
+                  <a:schemeClr val="tx2">
+                    <a:lumMod val="75000"/>
+                  </a:schemeClr>
+                </a:solidFill>
+                <a:latin typeface="Adagio_Slab"/>
+              </a:rPr>
+              <a:t>Language-</a:t>
+            </a:r>
+            <a:r>
+              <a:rPr lang="pl-PL" sz="3200" b="1" i="1" dirty="0" err="1">
+                <a:solidFill>
+                  <a:schemeClr val="tx2">
+                    <a:lumMod val="75000"/>
+                  </a:schemeClr>
+                </a:solidFill>
+                <a:latin typeface="Adagio_Slab"/>
+              </a:rPr>
+              <a:t>Guided</a:t>
+            </a:r>
+            <a:r>
+              <a:rPr lang="pl-PL" sz="3200" b="1" i="1" dirty="0">
+                <a:solidFill>
+                  <a:schemeClr val="tx2">
+                    <a:lumMod val="75000"/>
+                  </a:schemeClr>
+                </a:solidFill>
+                <a:latin typeface="Adagio_Slab"/>
+              </a:rPr>
+              <a:t> Query </a:t>
+            </a:r>
+            <a:r>
+              <a:rPr lang="pl-PL" sz="3200" b="1" i="1" dirty="0" err="1">
+                <a:solidFill>
+                  <a:schemeClr val="tx2">
+                    <a:lumMod val="75000"/>
+                  </a:schemeClr>
+                </a:solidFill>
+                <a:latin typeface="Adagio_Slab"/>
+              </a:rPr>
+              <a:t>Selection</a:t>
+            </a:r>
+            <a:r>
+              <a:rPr lang="pl-PL" sz="3200" b="1" dirty="0">
+                <a:solidFill>
+                  <a:schemeClr val="tx2">
+                    <a:lumMod val="75000"/>
+                  </a:schemeClr>
+                </a:solidFill>
+                <a:latin typeface="Adagio_Slab"/>
+              </a:rPr>
+              <a:t>:</a:t>
+            </a:r>
+            <a:endParaRPr lang="pl-PL" sz="3200" dirty="0">
+              <a:solidFill>
+                <a:schemeClr val="tx2">
+                  <a:lumMod val="75000"/>
+                </a:schemeClr>
+              </a:solidFill>
+              <a:latin typeface="Adagio_Slab"/>
+            </a:endParaRPr>
+          </a:p>
+          <a:p>
+            <a:pPr lvl="2"/>
+            <a:r>
+              <a:rPr lang="pl-PL" sz="3200" dirty="0">
+                <a:solidFill>
+                  <a:schemeClr val="tx2">
+                    <a:lumMod val="75000"/>
+                  </a:schemeClr>
+                </a:solidFill>
+                <a:latin typeface="Adagio_Slab"/>
+              </a:rPr>
+              <a:t>		Wybór kwerend sterowany językiem. </a:t>
+            </a:r>
+          </a:p>
+          <a:p>
+            <a:pPr lvl="1"/>
+            <a:r>
+              <a:rPr lang="pl-PL" sz="3200" b="1" dirty="0">
+                <a:solidFill>
+                  <a:schemeClr val="tx2">
+                    <a:lumMod val="75000"/>
+                  </a:schemeClr>
+                </a:solidFill>
+                <a:latin typeface="Adagio_Slab"/>
+              </a:rPr>
+              <a:t>	Faza 3 - </a:t>
+            </a:r>
+            <a:r>
+              <a:rPr lang="pl-PL" sz="3200" b="1" i="1" dirty="0">
+                <a:solidFill>
+                  <a:schemeClr val="tx2">
+                    <a:lumMod val="75000"/>
+                  </a:schemeClr>
+                </a:solidFill>
+                <a:latin typeface="Adagio_Slab"/>
+              </a:rPr>
+              <a:t>Cross-</a:t>
+            </a:r>
+            <a:r>
+              <a:rPr lang="pl-PL" sz="3200" b="1" i="1" dirty="0" err="1">
+                <a:solidFill>
+                  <a:schemeClr val="tx2">
+                    <a:lumMod val="75000"/>
+                  </a:schemeClr>
+                </a:solidFill>
+                <a:latin typeface="Adagio_Slab"/>
+              </a:rPr>
+              <a:t>Modality</a:t>
+            </a:r>
+            <a:r>
+              <a:rPr lang="pl-PL" sz="3200" b="1" i="1" dirty="0">
+                <a:solidFill>
+                  <a:schemeClr val="tx2">
+                    <a:lumMod val="75000"/>
+                  </a:schemeClr>
+                </a:solidFill>
+                <a:latin typeface="Adagio_Slab"/>
+              </a:rPr>
+              <a:t> </a:t>
+            </a:r>
+            <a:r>
+              <a:rPr lang="pl-PL" sz="3200" b="1" i="1" dirty="0" err="1">
+                <a:solidFill>
+                  <a:schemeClr val="tx2">
+                    <a:lumMod val="75000"/>
+                  </a:schemeClr>
+                </a:solidFill>
+                <a:latin typeface="Adagio_Slab"/>
+              </a:rPr>
+              <a:t>Decoder</a:t>
+            </a:r>
+            <a:r>
+              <a:rPr lang="pl-PL" sz="3200" b="1" dirty="0">
+                <a:solidFill>
+                  <a:schemeClr val="tx2">
+                    <a:lumMod val="75000"/>
+                  </a:schemeClr>
+                </a:solidFill>
+                <a:latin typeface="Adagio_Slab"/>
+              </a:rPr>
+              <a:t>:</a:t>
+            </a:r>
+            <a:endParaRPr lang="pl-PL" sz="3200" dirty="0">
+              <a:solidFill>
+                <a:schemeClr val="tx2">
+                  <a:lumMod val="75000"/>
+                </a:schemeClr>
+              </a:solidFill>
+              <a:latin typeface="Adagio_Slab"/>
+            </a:endParaRPr>
+          </a:p>
+          <a:p>
+            <a:pPr lvl="2"/>
+            <a:r>
+              <a:rPr lang="pl-PL" sz="3200" dirty="0">
+                <a:solidFill>
+                  <a:schemeClr val="tx2">
+                    <a:lumMod val="75000"/>
+                  </a:schemeClr>
+                </a:solidFill>
+                <a:latin typeface="Adagio_Slab"/>
+              </a:rPr>
+              <a:t>		Uszczegóławianie propozycji 			obiektów w warstwach dekodera.</a:t>
+            </a:r>
+          </a:p>
+        </p:txBody>
+      </p:sp>
+      <p:sp>
+        <p:nvSpPr>
+          <p:cNvPr id="6" name="pole tekstowe 5">
+            <a:extLst>
+              <a:ext uri="{FF2B5EF4-FFF2-40B4-BE49-F238E27FC236}">
+                <a16:creationId xmlns:a16="http://schemas.microsoft.com/office/drawing/2014/main" id="{794AC01E-B69C-0A9A-2393-FBDE7D1B735E}"/>
+              </a:ext>
+            </a:extLst>
+          </p:cNvPr>
+          <p:cNvSpPr txBox="1"/>
+          <p:nvPr/>
+        </p:nvSpPr>
+        <p:spPr>
+          <a:xfrm>
+            <a:off x="12500936" y="11118356"/>
+            <a:ext cx="7428374" cy="705251"/>
+          </a:xfrm>
+          <a:prstGeom prst="rect">
+            <a:avLst/>
+          </a:prstGeom>
+          <a:noFill/>
+          <a:ln w="12700" cap="flat">
+            <a:noFill/>
+            <a:miter lim="400000"/>
+          </a:ln>
+          <a:effectLst/>
+          <a:sp3d/>
+        </p:spPr>
+        <p:style>
+          <a:lnRef idx="0">
+            <a:scrgbClr r="0" g="0" b="0"/>
+          </a:lnRef>
+          <a:fillRef idx="0">
+            <a:scrgbClr r="0" g="0" b="0"/>
+          </a:fillRef>
+          <a:effectRef idx="0">
+            <a:scrgbClr r="0" g="0" b="0"/>
+          </a:effectRef>
+          <a:fontRef idx="none"/>
+        </p:style>
+        <p:txBody>
+          <a:bodyPr rot="0" spcFirstLastPara="1" vertOverflow="overflow" horzOverflow="overflow" vert="horz" wrap="square" lIns="110709" tIns="110709" rIns="110709" bIns="110709" numCol="1" spcCol="38100" rtlCol="0" anchor="t">
+            <a:spAutoFit/>
+          </a:bodyPr>
+          <a:lstStyle/>
+          <a:p>
+            <a:pPr marL="0" marR="0" indent="0" algn="l" defTabSz="1087437" rtl="0" fontAlgn="auto" latinLnBrk="0" hangingPunct="0">
+              <a:lnSpc>
+                <a:spcPct val="120000"/>
+              </a:lnSpc>
+              <a:spcBef>
+                <a:spcPts val="300"/>
+              </a:spcBef>
+              <a:spcAft>
+                <a:spcPts val="0"/>
+              </a:spcAft>
+              <a:buClrTx/>
+              <a:buSzTx/>
+              <a:buFontTx/>
+              <a:buNone/>
+              <a:tabLst/>
+            </a:pPr>
+            <a:r>
+              <a:rPr lang="pl-PL" sz="2400" dirty="0">
+                <a:solidFill>
+                  <a:schemeClr val="bg2">
+                    <a:lumMod val="75000"/>
+                  </a:schemeClr>
+                </a:solidFill>
+                <a:latin typeface="Adagio_Slab"/>
+              </a:rPr>
+              <a:t>Wizualizacja architektury modelu Grounding DINO</a:t>
+            </a:r>
+            <a:endParaRPr kumimoji="0" lang="pl-PL" sz="2400" b="0" i="0" u="none" strike="noStrike" cap="none" spc="0" normalizeH="0" baseline="0" dirty="0">
+              <a:ln>
+                <a:noFill/>
+              </a:ln>
+              <a:solidFill>
+                <a:schemeClr val="bg2">
+                  <a:lumMod val="75000"/>
+                </a:schemeClr>
+              </a:solidFill>
+              <a:effectLst/>
+              <a:uFillTx/>
+              <a:latin typeface="Adagio_Slab"/>
+              <a:sym typeface="Times New Roman"/>
+            </a:endParaRPr>
+          </a:p>
+        </p:txBody>
+      </p:sp>
     </p:spTree>
     <p:extLst>
       <p:ext uri="{BB962C8B-B14F-4D97-AF65-F5344CB8AC3E}">
@@ -4485,7 +6569,7 @@
           </a:prstGeom>
           <a:extLst>
             <a:ext uri="{C572A759-6A51-4108-AA02-DFA0A04FC94B}">
-              <ma14:wrappingTextBoxFlag xmlns:ma14="http://schemas.microsoft.com/office/mac/drawingml/2011/main" xmlns="" val="1"/>
+              <ma14:wrappingTextBoxFlag xmlns="" xmlns:ma14="http://schemas.microsoft.com/office/mac/drawingml/2011/main" val="1"/>
             </a:ext>
           </a:extLst>
         </p:spPr>
@@ -4578,7 +6662,7 @@
           </a:ln>
           <a:extLst>
             <a:ext uri="{C572A759-6A51-4108-AA02-DFA0A04FC94B}">
-              <ma14:wrappingTextBoxFlag xmlns:ma14="http://schemas.microsoft.com/office/mac/drawingml/2011/main" xmlns="" val="1"/>
+              <ma14:wrappingTextBoxFlag xmlns="" xmlns:ma14="http://schemas.microsoft.com/office/mac/drawingml/2011/main" val="1"/>
             </a:ext>
           </a:extLst>
         </p:spPr>
@@ -4686,7 +6770,7 @@
           </a:prstGeom>
           <a:extLst>
             <a:ext uri="{C572A759-6A51-4108-AA02-DFA0A04FC94B}">
-              <ma14:wrappingTextBoxFlag xmlns:ma14="http://schemas.microsoft.com/office/mac/drawingml/2011/main" xmlns="" val="1"/>
+              <ma14:wrappingTextBoxFlag xmlns="" xmlns:ma14="http://schemas.microsoft.com/office/mac/drawingml/2011/main" val="1"/>
             </a:ext>
           </a:extLst>
         </p:spPr>
@@ -4779,7 +6863,7 @@
           </a:ln>
           <a:extLst>
             <a:ext uri="{C572A759-6A51-4108-AA02-DFA0A04FC94B}">
-              <ma14:wrappingTextBoxFlag xmlns:ma14="http://schemas.microsoft.com/office/mac/drawingml/2011/main" xmlns="" val="1"/>
+              <ma14:wrappingTextBoxFlag xmlns="" xmlns:ma14="http://schemas.microsoft.com/office/mac/drawingml/2011/main" val="1"/>
             </a:ext>
           </a:extLst>
         </p:spPr>
@@ -5133,7 +7217,7 @@
             </a:ln>
             <a:extLst>
               <a:ext uri="{C572A759-6A51-4108-AA02-DFA0A04FC94B}">
-                <ma14:wrappingTextBoxFlag xmlns:ma14="http://schemas.microsoft.com/office/mac/drawingml/2011/main" xmlns="" val="1"/>
+                <ma14:wrappingTextBoxFlag xmlns="" xmlns:ma14="http://schemas.microsoft.com/office/mac/drawingml/2011/main" val="1"/>
               </a:ext>
             </a:extLst>
           </p:spPr>
@@ -5455,7 +7539,7 @@
             </a:ln>
             <a:extLst>
               <a:ext uri="{C572A759-6A51-4108-AA02-DFA0A04FC94B}">
-                <ma14:wrappingTextBoxFlag xmlns:ma14="http://schemas.microsoft.com/office/mac/drawingml/2011/main" xmlns="" val="1"/>
+                <ma14:wrappingTextBoxFlag xmlns="" xmlns:ma14="http://schemas.microsoft.com/office/mac/drawingml/2011/main" val="1"/>
               </a:ext>
             </a:extLst>
           </p:spPr>
@@ -5761,7 +7845,7 @@
             </a:ln>
             <a:extLst>
               <a:ext uri="{C572A759-6A51-4108-AA02-DFA0A04FC94B}">
-                <ma14:wrappingTextBoxFlag xmlns:ma14="http://schemas.microsoft.com/office/mac/drawingml/2011/main" xmlns="" val="1"/>
+                <ma14:wrappingTextBoxFlag xmlns="" xmlns:ma14="http://schemas.microsoft.com/office/mac/drawingml/2011/main" val="1"/>
               </a:ext>
             </a:extLst>
           </p:spPr>
@@ -6083,7 +8167,7 @@
             </a:ln>
             <a:extLst>
               <a:ext uri="{C572A759-6A51-4108-AA02-DFA0A04FC94B}">
-                <ma14:wrappingTextBoxFlag xmlns:ma14="http://schemas.microsoft.com/office/mac/drawingml/2011/main" xmlns="" val="1"/>
+                <ma14:wrappingTextBoxFlag xmlns="" xmlns:ma14="http://schemas.microsoft.com/office/mac/drawingml/2011/main" val="1"/>
               </a:ext>
             </a:extLst>
           </p:spPr>
@@ -6469,7 +8553,7 @@
             </a:ln>
             <a:extLst>
               <a:ext uri="{C572A759-6A51-4108-AA02-DFA0A04FC94B}">
-                <ma14:wrappingTextBoxFlag xmlns:ma14="http://schemas.microsoft.com/office/mac/drawingml/2011/main" xmlns="" val="1"/>
+                <ma14:wrappingTextBoxFlag xmlns="" xmlns:ma14="http://schemas.microsoft.com/office/mac/drawingml/2011/main" val="1"/>
               </a:ext>
             </a:extLst>
           </p:spPr>
@@ -6818,7 +8902,7 @@
             </a:ln>
             <a:extLst>
               <a:ext uri="{C572A759-6A51-4108-AA02-DFA0A04FC94B}">
-                <ma14:wrappingTextBoxFlag xmlns:ma14="http://schemas.microsoft.com/office/mac/drawingml/2011/main" xmlns="" val="1"/>
+                <ma14:wrappingTextBoxFlag xmlns="" xmlns:ma14="http://schemas.microsoft.com/office/mac/drawingml/2011/main" val="1"/>
               </a:ext>
             </a:extLst>
           </p:spPr>
@@ -7305,7 +9389,7 @@
           </a:prstGeom>
           <a:extLst>
             <a:ext uri="{C572A759-6A51-4108-AA02-DFA0A04FC94B}">
-              <ma14:wrappingTextBoxFlag xmlns:ma14="http://schemas.microsoft.com/office/mac/drawingml/2011/main" xmlns="" val="1"/>
+              <ma14:wrappingTextBoxFlag xmlns="" xmlns:ma14="http://schemas.microsoft.com/office/mac/drawingml/2011/main" val="1"/>
             </a:ext>
           </a:extLst>
         </p:spPr>
@@ -7398,7 +9482,7 @@
           </a:ln>
           <a:extLst>
             <a:ext uri="{C572A759-6A51-4108-AA02-DFA0A04FC94B}">
-              <ma14:wrappingTextBoxFlag xmlns:ma14="http://schemas.microsoft.com/office/mac/drawingml/2011/main" xmlns="" val="1"/>
+              <ma14:wrappingTextBoxFlag xmlns="" xmlns:ma14="http://schemas.microsoft.com/office/mac/drawingml/2011/main" val="1"/>
             </a:ext>
           </a:extLst>
         </p:spPr>
@@ -8460,7 +10544,7 @@
           </a:ln>
           <a:extLst>
             <a:ext uri="{C572A759-6A51-4108-AA02-DFA0A04FC94B}">
-              <ma14:wrappingTextBoxFlag xmlns:ma14="http://schemas.microsoft.com/office/mac/drawingml/2011/main" xmlns="" val="1"/>
+              <ma14:wrappingTextBoxFlag xmlns="" xmlns:ma14="http://schemas.microsoft.com/office/mac/drawingml/2011/main" val="1"/>
             </a:ext>
           </a:extLst>
         </p:spPr>

</xml_diff>